<commit_message>
docs(deck): full 20-question Q&A backup + 8-minute timing cues
- Q&A backup expanded from 6 to all 20 pairs from docs/07, grouped into
  5 slides (資料與方法 / 預測模型 / Speed Loss·ISO 19030 / UWI·商務 /
  AI·AWS·限制), concise reference answers.
- Every main slide's speaker notes now carry a time budget
  ([0:00–0:30] … [7:35–8:00]) so the 8-minute talk is paced.
- Deck now 16 slides (11 main + 5 Q&A backup); schema-validated, QA'd.

Co-Authored-By: Claude Opus 4.8 <noreply@anthropic.com>
</commit_message>
<xml_diff>
--- a/presentation/fleetmind-proposal-deck.pptx
+++ b/presentation/fleetmind-proposal-deck.pptx
@@ -18,9 +18,12 @@
     <p:sldId id="266" r:id="rId12"/>
     <p:sldId id="267" r:id="rId13"/>
     <p:sldId id="268" r:id="rId14"/>
+    <p:sldId id="269" r:id="rId15"/>
+    <p:sldId id="270" r:id="rId16"/>
+    <p:sldId id="271" r:id="rId17"/>
   </p:sldIdLst>
   <p:notesMasterIdLst>
-    <p:notesMasterId r:id="rId15"/>
+    <p:notesMasterId r:id="rId18"/>
   </p:notesMasterIdLst>
   <p:sldSz cx="12191695" cy="6858000"/>
   <p:notesSz cx="6858000" cy="12191695"/>
@@ -775,7 +778,7 @@
           <a:p>
             <a:r>
               <a:rPr lang="en-US" dirty="0"/>
-              <a:t>開場 30 秒：船舶推進效率隨時間衰退、油耗上升；養護能恢復但決策靠經驗。FleetMind 把它變成可計算、可解釋、人可拍板的決策支援。一句話定位：數字來自計算，語言來自 AI，決策留給人。</a:t>
+              <a:t>[0:00–0:30] 開場：船舶推進效率隨時間衰退、油耗上升；養護能恢復但決策靠經驗。FleetMind 把它變成可計算、可解釋、人可拍板的決策支援。一句話定位：數字來自計算，語言來自 AI，決策留給人。</a:t>
             </a:r>
             <a:endParaRPr lang="en-US" dirty="0"/>
           </a:p>
@@ -863,7 +866,7 @@
           <a:p>
             <a:r>
               <a:rPr lang="en-US" dirty="0"/>
-              <a:t>架構一句話：單服務同源、AWS-only、AI 有 guardrail 不亂編。回應官方第 4、5 項。</a:t>
+              <a:t>[6:55–7:35] 架構一句話：單服務同源、AWS-only、AI 有 guardrail 不亂編。回應官方第 4、5 項。</a:t>
             </a:r>
             <a:endParaRPr lang="en-US" dirty="0"/>
           </a:p>
@@ -951,7 +954,7 @@
           <a:p>
             <a:r>
               <a:rPr lang="en-US" dirty="0"/>
-              <a:t>收尾：三個交付一句話帶過，回到定位句，進 Q&amp;A。</a:t>
+              <a:t>[7:35–8:00] 收尾：三個交付一句話帶過，回到定位句，進 Q&amp;A。</a:t>
             </a:r>
             <a:endParaRPr lang="en-US" dirty="0"/>
           </a:p>
@@ -1169,6 +1172,270 @@
 </p:notes>
 </file>
 
+<file path=ppt/notesSlides/notesSlide14.xml><?xml version="1.0" encoding="utf-8"?>
+<p:notes xmlns:a="http://schemas.openxmlformats.org/drawingml/2006/main" xmlns:r="http://schemas.openxmlformats.org/officeDocument/2006/relationships" xmlns:p="http://schemas.openxmlformats.org/presentationml/2006/main">
+  <p:cSld>
+    <p:spTree>
+      <p:nvGrpSpPr>
+        <p:cNvPr id="1" name=""/>
+        <p:cNvGrpSpPr/>
+        <p:nvPr/>
+      </p:nvGrpSpPr>
+      <p:grpSpPr>
+        <a:xfrm>
+          <a:off x="0" y="0"/>
+          <a:ext cx="0" cy="0"/>
+          <a:chOff x="0" y="0"/>
+          <a:chExt cx="0" cy="0"/>
+        </a:xfrm>
+      </p:grpSpPr>
+      <p:sp>
+        <p:nvSpPr>
+          <p:cNvPr id="2" name="Slide Image Placeholder 1"/>
+          <p:cNvSpPr>
+            <a:spLocks noGrp="1" noRot="1" noChangeAspect="1"/>
+          </p:cNvSpPr>
+          <p:nvPr>
+            <p:ph type="sldImg"/>
+          </p:nvPr>
+        </p:nvSpPr>
+        <p:spPr/>
+      </p:sp>
+      <p:sp>
+        <p:nvSpPr>
+          <p:cNvPr id="3" name="Notes Placeholder 2"/>
+          <p:cNvSpPr>
+            <a:spLocks noGrp="1"/>
+          </p:cNvSpPr>
+          <p:nvPr>
+            <p:ph type="body" idx="1"/>
+          </p:nvPr>
+        </p:nvSpPr>
+        <p:spPr/>
+        <p:txBody>
+          <a:bodyPr/>
+          <a:lstStyle/>
+          <a:p>
+            <a:r>
+              <a:rPr lang="en-US" dirty="0"/>
+              <a:t/>
+            </a:r>
+            <a:endParaRPr lang="en-US" dirty="0"/>
+          </a:p>
+        </p:txBody>
+      </p:sp>
+      <p:sp>
+        <p:nvSpPr>
+          <p:cNvPr id="4" name="Slide Number Placeholder 3"/>
+          <p:cNvSpPr>
+            <a:spLocks noGrp="1"/>
+          </p:cNvSpPr>
+          <p:nvPr>
+            <p:ph type="sldNum" sz="quarter" idx="10"/>
+          </p:nvPr>
+        </p:nvSpPr>
+        <p:spPr/>
+        <p:txBody>
+          <a:bodyPr/>
+          <a:lstStyle/>
+          <a:p>
+            <a:fld id="{F7021451-1387-4CA6-816F-3879F97B5CBC}" type="slidenum">
+              <a:rPr lang="en-US"/>
+              <a:t>14</a:t>
+            </a:fld>
+            <a:endParaRPr lang="en-US"/>
+          </a:p>
+        </p:txBody>
+      </p:sp>
+    </p:spTree>
+    <p:extLst>
+      <p:ext uri="{BB962C8B-B14F-4D97-AF65-F5344CB8AC3E}">
+        <p14:creationId xmlns:p14="http://schemas.microsoft.com/office/powerpoint/2010/main" val="1024086991"/>
+      </p:ext>
+    </p:extLst>
+  </p:cSld>
+  <p:clrMapOvr>
+    <a:masterClrMapping/>
+  </p:clrMapOvr>
+</p:notes>
+</file>
+
+<file path=ppt/notesSlides/notesSlide15.xml><?xml version="1.0" encoding="utf-8"?>
+<p:notes xmlns:a="http://schemas.openxmlformats.org/drawingml/2006/main" xmlns:r="http://schemas.openxmlformats.org/officeDocument/2006/relationships" xmlns:p="http://schemas.openxmlformats.org/presentationml/2006/main">
+  <p:cSld>
+    <p:spTree>
+      <p:nvGrpSpPr>
+        <p:cNvPr id="1" name=""/>
+        <p:cNvGrpSpPr/>
+        <p:nvPr/>
+      </p:nvGrpSpPr>
+      <p:grpSpPr>
+        <a:xfrm>
+          <a:off x="0" y="0"/>
+          <a:ext cx="0" cy="0"/>
+          <a:chOff x="0" y="0"/>
+          <a:chExt cx="0" cy="0"/>
+        </a:xfrm>
+      </p:grpSpPr>
+      <p:sp>
+        <p:nvSpPr>
+          <p:cNvPr id="2" name="Slide Image Placeholder 1"/>
+          <p:cNvSpPr>
+            <a:spLocks noGrp="1" noRot="1" noChangeAspect="1"/>
+          </p:cNvSpPr>
+          <p:nvPr>
+            <p:ph type="sldImg"/>
+          </p:nvPr>
+        </p:nvSpPr>
+        <p:spPr/>
+      </p:sp>
+      <p:sp>
+        <p:nvSpPr>
+          <p:cNvPr id="3" name="Notes Placeholder 2"/>
+          <p:cNvSpPr>
+            <a:spLocks noGrp="1"/>
+          </p:cNvSpPr>
+          <p:nvPr>
+            <p:ph type="body" idx="1"/>
+          </p:nvPr>
+        </p:nvSpPr>
+        <p:spPr/>
+        <p:txBody>
+          <a:bodyPr/>
+          <a:lstStyle/>
+          <a:p>
+            <a:r>
+              <a:rPr lang="en-US" dirty="0"/>
+              <a:t/>
+            </a:r>
+            <a:endParaRPr lang="en-US" dirty="0"/>
+          </a:p>
+        </p:txBody>
+      </p:sp>
+      <p:sp>
+        <p:nvSpPr>
+          <p:cNvPr id="4" name="Slide Number Placeholder 3"/>
+          <p:cNvSpPr>
+            <a:spLocks noGrp="1"/>
+          </p:cNvSpPr>
+          <p:nvPr>
+            <p:ph type="sldNum" sz="quarter" idx="10"/>
+          </p:nvPr>
+        </p:nvSpPr>
+        <p:spPr/>
+        <p:txBody>
+          <a:bodyPr/>
+          <a:lstStyle/>
+          <a:p>
+            <a:fld id="{F7021451-1387-4CA6-816F-3879F97B5CBC}" type="slidenum">
+              <a:rPr lang="en-US"/>
+              <a:t>15</a:t>
+            </a:fld>
+            <a:endParaRPr lang="en-US"/>
+          </a:p>
+        </p:txBody>
+      </p:sp>
+    </p:spTree>
+    <p:extLst>
+      <p:ext uri="{BB962C8B-B14F-4D97-AF65-F5344CB8AC3E}">
+        <p14:creationId xmlns:p14="http://schemas.microsoft.com/office/powerpoint/2010/main" val="1024086991"/>
+      </p:ext>
+    </p:extLst>
+  </p:cSld>
+  <p:clrMapOvr>
+    <a:masterClrMapping/>
+  </p:clrMapOvr>
+</p:notes>
+</file>
+
+<file path=ppt/notesSlides/notesSlide16.xml><?xml version="1.0" encoding="utf-8"?>
+<p:notes xmlns:a="http://schemas.openxmlformats.org/drawingml/2006/main" xmlns:r="http://schemas.openxmlformats.org/officeDocument/2006/relationships" xmlns:p="http://schemas.openxmlformats.org/presentationml/2006/main">
+  <p:cSld>
+    <p:spTree>
+      <p:nvGrpSpPr>
+        <p:cNvPr id="1" name=""/>
+        <p:cNvGrpSpPr/>
+        <p:nvPr/>
+      </p:nvGrpSpPr>
+      <p:grpSpPr>
+        <a:xfrm>
+          <a:off x="0" y="0"/>
+          <a:ext cx="0" cy="0"/>
+          <a:chOff x="0" y="0"/>
+          <a:chExt cx="0" cy="0"/>
+        </a:xfrm>
+      </p:grpSpPr>
+      <p:sp>
+        <p:nvSpPr>
+          <p:cNvPr id="2" name="Slide Image Placeholder 1"/>
+          <p:cNvSpPr>
+            <a:spLocks noGrp="1" noRot="1" noChangeAspect="1"/>
+          </p:cNvSpPr>
+          <p:nvPr>
+            <p:ph type="sldImg"/>
+          </p:nvPr>
+        </p:nvSpPr>
+        <p:spPr/>
+      </p:sp>
+      <p:sp>
+        <p:nvSpPr>
+          <p:cNvPr id="3" name="Notes Placeholder 2"/>
+          <p:cNvSpPr>
+            <a:spLocks noGrp="1"/>
+          </p:cNvSpPr>
+          <p:nvPr>
+            <p:ph type="body" idx="1"/>
+          </p:nvPr>
+        </p:nvSpPr>
+        <p:spPr/>
+        <p:txBody>
+          <a:bodyPr/>
+          <a:lstStyle/>
+          <a:p>
+            <a:r>
+              <a:rPr lang="en-US" dirty="0"/>
+              <a:t/>
+            </a:r>
+            <a:endParaRPr lang="en-US" dirty="0"/>
+          </a:p>
+        </p:txBody>
+      </p:sp>
+      <p:sp>
+        <p:nvSpPr>
+          <p:cNvPr id="4" name="Slide Number Placeholder 3"/>
+          <p:cNvSpPr>
+            <a:spLocks noGrp="1"/>
+          </p:cNvSpPr>
+          <p:nvPr>
+            <p:ph type="sldNum" sz="quarter" idx="10"/>
+          </p:nvPr>
+        </p:nvSpPr>
+        <p:spPr/>
+        <p:txBody>
+          <a:bodyPr/>
+          <a:lstStyle/>
+          <a:p>
+            <a:fld id="{F7021451-1387-4CA6-816F-3879F97B5CBC}" type="slidenum">
+              <a:rPr lang="en-US"/>
+              <a:t>16</a:t>
+            </a:fld>
+            <a:endParaRPr lang="en-US"/>
+          </a:p>
+        </p:txBody>
+      </p:sp>
+    </p:spTree>
+    <p:extLst>
+      <p:ext uri="{BB962C8B-B14F-4D97-AF65-F5344CB8AC3E}">
+        <p14:creationId xmlns:p14="http://schemas.microsoft.com/office/powerpoint/2010/main" val="1024086991"/>
+      </p:ext>
+    </p:extLst>
+  </p:cSld>
+  <p:clrMapOvr>
+    <a:masterClrMapping/>
+  </p:clrMapOvr>
+</p:notes>
+</file>
+
 <file path=ppt/notesSlides/notesSlide2.xml><?xml version="1.0" encoding="utf-8"?>
 <p:notes xmlns:a="http://schemas.openxmlformats.org/drawingml/2006/main" xmlns:r="http://schemas.openxmlformats.org/officeDocument/2006/relationships" xmlns:p="http://schemas.openxmlformats.org/presentationml/2006/main">
   <p:cSld>
@@ -1215,7 +1482,7 @@
           <a:p>
             <a:r>
               <a:rPr lang="en-US" dirty="0"/>
-              <a:t>點出痛點：污損偷油、養護決策靠經驗。用真資料規模帶出我們有本錢做量化。</a:t>
+              <a:t>[0:30–1:10] 點出痛點：污損偷油、養護決策靠經驗。用真資料規模帶出我們有本錢做量化。</a:t>
             </a:r>
             <a:endParaRPr lang="en-US" dirty="0"/>
           </a:p>
@@ -1303,7 +1570,7 @@
           <a:p>
             <a:r>
               <a:rPr lang="en-US" dirty="0"/>
-              <a:t>兩個產出對應 30%+25% 硬分數；其餘三維度靠 ROI、單服務架構、AI guardrail。</a:t>
+              <a:t>[1:10–1:50] 兩個產出對應 30%+25% 硬分數；其餘三維度靠 ROI、單服務架構、AI guardrail。</a:t>
             </a:r>
             <a:endParaRPr lang="en-US" dirty="0"/>
           </a:p>
@@ -1391,7 +1658,7 @@
           <a:p>
             <a:r>
               <a:rPr lang="en-US" dirty="0"/>
-              <a:t>方法核心：k=FOC/STW³ 把速度與洋流正規化，只在同速帶比 k，減速不會被誤記成污損。</a:t>
+              <a:t>[1:50–2:35] 方法核心：k=FOC/STW³ 把速度與洋流正規化，只在同速帶比 k，減速不會被誤記成污損。</a:t>
             </a:r>
             <a:endParaRPr lang="en-US" dirty="0"/>
           </a:p>
@@ -1479,7 +1746,7 @@
           <a:p>
             <a:r>
               <a:rPr lang="en-US" dirty="0"/>
-              <a:t>Demo：真資料 15 船，點 S11（最嚴重、692 天沒清）看趨勢；再點 S23 看歸因。強調數字全來自 core-calc 確定性計算。</a:t>
+              <a:t>[2:35–3:35] Demo（最長，實機操作）：真資料 15 船，點 S11（最嚴重、692 天沒清）看趨勢；再點 S23 看歸因。強調數字全來自 core-calc 確定性計算。</a:t>
             </a:r>
             <a:endParaRPr lang="en-US" dirty="0"/>
           </a:p>
@@ -1567,7 +1834,7 @@
           <a:p>
             <a:r>
               <a:rPr lang="en-US" dirty="0"/>
-              <a:t>這頁是誠信亮點。把物理先驗（模型時鐘不重置）和統計實測（dashboard 顯示雜訊）分開，準備好回答『你模型說 UWI 不改善但圖上有變化』。</a:t>
+              <a:t>[3:35–4:25] 這頁是誠信亮點。把物理先驗（模型時鐘不重置）和統計實測（dashboard 顯示雜訊）分開，準備好回答『你模型說 UWI 不改善但圖上有變化』。</a:t>
             </a:r>
             <a:endParaRPr lang="en-US" dirty="0"/>
           </a:p>
@@ -1655,7 +1922,7 @@
           <a:p>
             <a:r>
               <a:rPr lang="en-US" dirty="0"/>
-              <a:t>誠實：baseline 勝出。強調防漏驗證的嚴謹（模擬真實遮蔽），這是評審會追問的點。</a:t>
+              <a:t>[4:25–5:25] 誠實：baseline 勝出。強調防漏驗證的嚴謹（模擬真實遮蔽），這是評審會追問的點。</a:t>
             </a:r>
             <a:endParaRPr lang="en-US" dirty="0"/>
           </a:p>
@@ -1743,7 +2010,7 @@
           <a:p>
             <a:r>
               <a:rPr lang="en-US" dirty="0"/>
-              <a:t>主打 S23（HIGH 信心、船殼 96%）：清一次年省近 400 萬美金。S11 是極端案例。強調人在迴路、數字可回溯。</a:t>
+              <a:t>[5:25–6:20] 主打 S23（HIGH 信心、船殼 96%）：清一次年省近 400 萬美金。S11 是極端案例。強調人在迴路、數字可回溯。</a:t>
             </a:r>
             <a:endParaRPr lang="en-US" dirty="0"/>
           </a:p>
@@ -1831,7 +2098,7 @@
           <a:p>
             <a:r>
               <a:rPr lang="en-US" dirty="0"/>
-              <a:t>主動揭露限制 = 誠信分。同時把『要什麼資料』講清楚，回應官方必含第 3 項與商務價值。</a:t>
+              <a:t>[6:20–6:55] 主動揭露限制 = 誠信分。同時把『要什麼資料』講清楚，回應官方必含第 3 項與商務價值。</a:t>
             </a:r>
             <a:endParaRPr lang="en-US" dirty="0"/>
           </a:p>
@@ -3854,7 +4121,7 @@
                 <a:ea typeface="Microsoft JhengHei" pitchFamily="34" charset="-122"/>
                 <a:cs typeface="Microsoft JhengHei" pitchFamily="34" charset="-120"/>
               </a:rPr>
-              <a:t>預測與驗證</a:t>
+              <a:t>資料與方法</a:t>
             </a:r>
             <a:endParaRPr lang="en-US" sz="3000" dirty="0"/>
           </a:p>
@@ -3868,24 +4135,24 @@
         </p:nvSpPr>
         <p:spPr>
           <a:xfrm>
-            <a:off x="640080" y="1737360"/>
-            <a:ext cx="10911535" cy="365760"/>
-          </a:xfrm>
-          <a:prstGeom prst="rect">
-            <a:avLst/>
-          </a:prstGeom>
-          <a:noFill/>
-          <a:ln/>
-        </p:spPr>
-        <p:txBody>
-          <a:bodyPr wrap="square" lIns="0" tIns="0" rIns="0" bIns="0" rtlCol="0" anchor="ctr"/>
-          <a:lstStyle/>
-          <a:p>
-            <a:pPr indent="0" marL="0">
-              <a:buNone/>
-            </a:pPr>
-            <a:r>
-              <a:rPr lang="en-US" sz="1500" b="1" dirty="0">
+            <a:off x="640080" y="1691640"/>
+            <a:ext cx="10911535" cy="320040"/>
+          </a:xfrm>
+          <a:prstGeom prst="rect">
+            <a:avLst/>
+          </a:prstGeom>
+          <a:noFill/>
+          <a:ln/>
+        </p:spPr>
+        <p:txBody>
+          <a:bodyPr wrap="square" lIns="0" tIns="0" rIns="0" bIns="0" rtlCol="0" anchor="ctr"/>
+          <a:lstStyle/>
+          <a:p>
+            <a:pPr indent="0" marL="0">
+              <a:buNone/>
+            </a:pPr>
+            <a:r>
+              <a:rPr lang="en-US" sz="1350" b="1" dirty="0">
                 <a:solidFill>
                   <a:srgbClr val="0A2540"/>
                 </a:solidFill>
@@ -3893,9 +4160,9 @@
                 <a:ea typeface="Microsoft JhengHei" pitchFamily="34" charset="-122"/>
                 <a:cs typeface="Microsoft JhengHei" pitchFamily="34" charset="-120"/>
               </a:rPr>
-              <a:t>Q　怎麼確定沒偷看答案？</a:t>
-            </a:r>
-            <a:endParaRPr lang="en-US" sz="1500" dirty="0"/>
+              <a:t>Q　拿到什麼資料？怎麼跟養護事件對上？</a:t>
+            </a:r>
+            <a:endParaRPr lang="en-US" sz="1350" dirty="0"/>
           </a:p>
         </p:txBody>
       </p:sp>
@@ -3907,8 +4174,8 @@
         </p:nvSpPr>
         <p:spPr>
           <a:xfrm>
-            <a:off x="640080" y="2121408"/>
-            <a:ext cx="10911535" cy="822960"/>
+            <a:off x="640080" y="2020824"/>
+            <a:ext cx="10911535" cy="850392"/>
           </a:xfrm>
           <a:prstGeom prst="rect">
             <a:avLst/>
@@ -3922,12 +4189,12 @@
           <a:p>
             <a:pPr indent="0" marL="0">
               <a:lnSpc>
-                <a:spcPct val="112000"/>
+                <a:spcPct val="108000"/>
               </a:lnSpc>
               <a:buNone/>
             </a:pPr>
             <a:r>
-              <a:rPr lang="en-US" sz="1250" dirty="0">
+              <a:rPr lang="en-US" sz="1150" dirty="0">
                 <a:solidFill>
                   <a:srgbClr val="18293B"/>
                 </a:solidFill>
@@ -3935,9 +4202,9 @@
                 <a:ea typeface="Microsoft JhengHei" pitchFamily="34" charset="-122"/>
                 <a:cs typeface="Microsoft JhengHei" pitchFamily="34" charset="-120"/>
               </a:rPr>
-              <a:t>A　不用隨機 K-fold。在可見船 S1–S12 上模擬真實遮蔽——挑真養護事件後的合格日窗把答案藏起來再預測、逐窗評 RMSE/MAPE；另跑 GroupKFold 確認跨船遷移。</a:t>
-            </a:r>
-            <a:endParaRPr lang="en-US" sz="1250" dirty="0"/>
+              <a:t>A　15 船×5 年日報（21,282 列）+ 77 養護事件。maintenance 用 event_day 與日報 NOON_UTC 同軸，直接 join，無日曆錨點問題。</a:t>
+            </a:r>
+            <a:endParaRPr lang="en-US" sz="1150" dirty="0"/>
           </a:p>
         </p:txBody>
       </p:sp>
@@ -3949,24 +4216,24 @@
         </p:nvSpPr>
         <p:spPr>
           <a:xfrm>
-            <a:off x="640080" y="3154680"/>
-            <a:ext cx="10911535" cy="365760"/>
-          </a:xfrm>
-          <a:prstGeom prst="rect">
-            <a:avLst/>
-          </a:prstGeom>
-          <a:noFill/>
-          <a:ln/>
-        </p:spPr>
-        <p:txBody>
-          <a:bodyPr wrap="square" lIns="0" tIns="0" rIns="0" bIns="0" rtlCol="0" anchor="ctr"/>
-          <a:lstStyle/>
-          <a:p>
-            <a:pPr indent="0" marL="0">
-              <a:buNone/>
-            </a:pPr>
-            <a:r>
-              <a:rPr lang="en-US" sz="1500" b="1" dirty="0">
+            <a:off x="640080" y="2926080"/>
+            <a:ext cx="10911535" cy="320040"/>
+          </a:xfrm>
+          <a:prstGeom prst="rect">
+            <a:avLst/>
+          </a:prstGeom>
+          <a:noFill/>
+          <a:ln/>
+        </p:spPr>
+        <p:txBody>
+          <a:bodyPr wrap="square" lIns="0" tIns="0" rIns="0" bIns="0" rtlCol="0" anchor="ctr"/>
+          <a:lstStyle/>
+          <a:p>
+            <a:pPr indent="0" marL="0">
+              <a:buNone/>
+            </a:pPr>
+            <a:r>
+              <a:rPr lang="en-US" sz="1350" b="1" dirty="0">
                 <a:solidFill>
                   <a:srgbClr val="0A2540"/>
                 </a:solidFill>
@@ -3974,9 +4241,9 @@
                 <a:ea typeface="Microsoft JhengHei" pitchFamily="34" charset="-122"/>
                 <a:cs typeface="Microsoft JhengHei" pitchFamily="34" charset="-120"/>
               </a:rPr>
-              <a:t>Q　RPM 不是幾乎能反推油耗？</a:t>
-            </a:r>
-            <a:endParaRPr lang="en-US" sz="1500" dirty="0"/>
+              <a:t>Q　只有 3 艘要預測，樣本夠嗎？</a:t>
+            </a:r>
+            <a:endParaRPr lang="en-US" sz="1350" dirty="0"/>
           </a:p>
         </p:txBody>
       </p:sp>
@@ -3988,8 +4255,8 @@
         </p:nvSpPr>
         <p:spPr>
           <a:xfrm>
-            <a:off x="640080" y="3538728"/>
-            <a:ext cx="10911535" cy="822960"/>
+            <a:off x="640080" y="3255264"/>
+            <a:ext cx="10911535" cy="850392"/>
           </a:xfrm>
           <a:prstGeom prst="rect">
             <a:avLst/>
@@ -4003,12 +4270,12 @@
           <a:p>
             <a:pPr indent="0" marL="0">
               <a:lnSpc>
-                <a:spcPct val="112000"/>
+                <a:spcPct val="108000"/>
               </a:lnSpc>
               <a:buNone/>
             </a:pPr>
             <a:r>
-              <a:rPr lang="en-US" sz="1250" dirty="0">
+              <a:rPr lang="en-US" sz="1150" dirty="0">
                 <a:solidFill>
                   <a:srgbClr val="18293B"/>
                 </a:solidFill>
@@ -4016,9 +4283,9 @@
                 <a:ea typeface="Microsoft JhengHei" pitchFamily="34" charset="-122"/>
                 <a:cs typeface="Microsoft JhengHei" pitchFamily="34" charset="-120"/>
               </a:rPr>
-              <a:t>A　H 類主機性能欄位（SFOC、馬力）在預測窗本就被遮蔽，我們不用。ME_AVG_RPM 屬可見的運轉條件、非答案代理；使用邊界也列入給主辦的問題。</a:t>
-            </a:r>
-            <a:endParaRPr lang="en-US" sz="1250" dirty="0"/>
+              <a:t>A　船型 W1/W2 姊妹船；預測船在同型訓練船上有大量可見歷史 → 遷移學習，正是官方要的能力。</a:t>
+            </a:r>
+            <a:endParaRPr lang="en-US" sz="1150" dirty="0"/>
           </a:p>
         </p:txBody>
       </p:sp>
@@ -4030,24 +4297,24 @@
         </p:nvSpPr>
         <p:spPr>
           <a:xfrm>
-            <a:off x="640080" y="4572000"/>
-            <a:ext cx="10911535" cy="365760"/>
-          </a:xfrm>
-          <a:prstGeom prst="rect">
-            <a:avLst/>
-          </a:prstGeom>
-          <a:noFill/>
-          <a:ln/>
-        </p:spPr>
-        <p:txBody>
-          <a:bodyPr wrap="square" lIns="0" tIns="0" rIns="0" bIns="0" rtlCol="0" anchor="ctr"/>
-          <a:lstStyle/>
-          <a:p>
-            <a:pPr indent="0" marL="0">
-              <a:buNone/>
-            </a:pPr>
-            <a:r>
-              <a:rPr lang="en-US" sz="1500" b="1" dirty="0">
+            <a:off x="640080" y="4160520"/>
+            <a:ext cx="10911535" cy="320040"/>
+          </a:xfrm>
+          <a:prstGeom prst="rect">
+            <a:avLst/>
+          </a:prstGeom>
+          <a:noFill/>
+          <a:ln/>
+        </p:spPr>
+        <p:txBody>
+          <a:bodyPr wrap="square" lIns="0" tIns="0" rIns="0" bIns="0" rtlCol="0" anchor="ctr"/>
+          <a:lstStyle/>
+          <a:p>
+            <a:pPr indent="0" marL="0">
+              <a:buNone/>
+            </a:pPr>
+            <a:r>
+              <a:rPr lang="en-US" sz="1350" b="1" dirty="0">
                 <a:solidFill>
                   <a:srgbClr val="0A2540"/>
                 </a:solidFill>
@@ -4055,9 +4322,9 @@
                 <a:ea typeface="Microsoft JhengHei" pitchFamily="34" charset="-122"/>
                 <a:cs typeface="Microsoft JhengHei" pitchFamily="34" charset="-120"/>
               </a:rPr>
-              <a:t>Q　整隊都降速了，怎麼分商業減速與污損？</a:t>
-            </a:r>
-            <a:endParaRPr lang="en-US" sz="1500" dirty="0"/>
+              <a:t>Q　STW 還是 SOG？洋流怎麼處理？</a:t>
+            </a:r>
+            <a:endParaRPr lang="en-US" sz="1350" dirty="0"/>
           </a:p>
         </p:txBody>
       </p:sp>
@@ -4069,8 +4336,8 @@
         </p:nvSpPr>
         <p:spPr>
           <a:xfrm>
-            <a:off x="640080" y="4956048"/>
-            <a:ext cx="10911535" cy="822960"/>
+            <a:off x="640080" y="4489704"/>
+            <a:ext cx="10911535" cy="850392"/>
           </a:xfrm>
           <a:prstGeom prst="rect">
             <a:avLst/>
@@ -4084,12 +4351,12 @@
           <a:p>
             <a:pPr indent="0" marL="0">
               <a:lnSpc>
-                <a:spcPct val="112000"/>
+                <a:spcPct val="108000"/>
               </a:lnSpc>
               <a:buNone/>
             </a:pPr>
             <a:r>
-              <a:rPr lang="en-US" sz="1250" dirty="0">
+              <a:rPr lang="en-US" sz="1150" dirty="0">
                 <a:solidFill>
                   <a:srgbClr val="18293B"/>
                 </a:solidFill>
@@ -4097,9 +4364,90 @@
                 <a:ea typeface="Microsoft JhengHei" pitchFamily="34" charset="-122"/>
                 <a:cs typeface="Microsoft JhengHei" pitchFamily="34" charset="-120"/>
               </a:rPr>
-              <a:t>A　從不比原始 FOC 或航速。k=FOC/STW³ 先正規化速度，只在 ±1 kn 同速帶內比 k；速度偏離自動降低信心。</a:t>
-            </a:r>
-            <a:endParaRPr lang="en-US" sz="1250" dirty="0"/>
+              <a:t>A　阻力物理一律用 STW（對水）；k=FOC/STW³ 正規化速度，只在 ±1 kn 同速帶比 k，洋流不會被誤記成污損。</a:t>
+            </a:r>
+            <a:endParaRPr lang="en-US" sz="1150" dirty="0"/>
+          </a:p>
+        </p:txBody>
+      </p:sp>
+      <p:sp>
+        <p:nvSpPr>
+          <p:cNvPr id="10" name="Text 8"/>
+          <p:cNvSpPr/>
+          <p:nvPr/>
+        </p:nvSpPr>
+        <p:spPr>
+          <a:xfrm>
+            <a:off x="640080" y="5394960"/>
+            <a:ext cx="10911535" cy="320040"/>
+          </a:xfrm>
+          <a:prstGeom prst="rect">
+            <a:avLst/>
+          </a:prstGeom>
+          <a:noFill/>
+          <a:ln/>
+        </p:spPr>
+        <p:txBody>
+          <a:bodyPr wrap="square" lIns="0" tIns="0" rIns="0" bIns="0" rtlCol="0" anchor="ctr"/>
+          <a:lstStyle/>
+          <a:p>
+            <a:pPr indent="0" marL="0">
+              <a:buNone/>
+            </a:pPr>
+            <a:r>
+              <a:rPr lang="en-US" sz="1350" b="1" dirty="0">
+                <a:solidFill>
+                  <a:srgbClr val="0A2540"/>
+                </a:solidFill>
+                <a:latin typeface="Microsoft JhengHei" pitchFamily="34" charset="0"/>
+                <a:ea typeface="Microsoft JhengHei" pitchFamily="34" charset="-122"/>
+                <a:cs typeface="Microsoft JhengHei" pitchFamily="34" charset="-120"/>
+              </a:rPr>
+              <a:t>Q　預測的到底是什麼值？</a:t>
+            </a:r>
+            <a:endParaRPr lang="en-US" sz="1350" dirty="0"/>
+          </a:p>
+        </p:txBody>
+      </p:sp>
+      <p:sp>
+        <p:nvSpPr>
+          <p:cNvPr id="11" name="Text 9"/>
+          <p:cNvSpPr/>
+          <p:nvPr/>
+        </p:nvSpPr>
+        <p:spPr>
+          <a:xfrm>
+            <a:off x="640080" y="5724144"/>
+            <a:ext cx="10911535" cy="850392"/>
+          </a:xfrm>
+          <a:prstGeom prst="rect">
+            <a:avLst/>
+          </a:prstGeom>
+          <a:noFill/>
+          <a:ln/>
+        </p:spPr>
+        <p:txBody>
+          <a:bodyPr wrap="square" lIns="0" tIns="0" rIns="0" bIns="0" rtlCol="0" anchor="ctr"/>
+          <a:lstStyle/>
+          <a:p>
+            <a:pPr indent="0" marL="0">
+              <a:lnSpc>
+                <a:spcPct val="108000"/>
+              </a:lnSpc>
+              <a:buNone/>
+            </a:pPr>
+            <a:r>
+              <a:rPr lang="en-US" sz="1150" dirty="0">
+                <a:solidFill>
+                  <a:srgbClr val="18293B"/>
+                </a:solidFill>
+                <a:latin typeface="Microsoft JhengHei" pitchFamily="34" charset="0"/>
+                <a:ea typeface="Microsoft JhengHei" pitchFamily="34" charset="-122"/>
+                <a:cs typeface="Microsoft JhengHei" pitchFamily="34" charset="-120"/>
+              </a:rPr>
+              <a:t>A　當日全速時段主機油耗總量（MT，原欄位語義），非 24h 正規化。內部以每小時率×全速時數還原。</a:t>
+            </a:r>
+            <a:endParaRPr lang="en-US" sz="1150" dirty="0"/>
           </a:p>
         </p:txBody>
       </p:sp>
@@ -4207,7 +4555,7 @@
                 <a:ea typeface="Microsoft JhengHei" pitchFamily="34" charset="-122"/>
                 <a:cs typeface="Microsoft JhengHei" pitchFamily="34" charset="-120"/>
               </a:rPr>
-              <a:t>方法與商務</a:t>
+              <a:t>預測模型</a:t>
             </a:r>
             <a:endParaRPr lang="en-US" sz="3000" dirty="0"/>
           </a:p>
@@ -4221,24 +4569,24 @@
         </p:nvSpPr>
         <p:spPr>
           <a:xfrm>
-            <a:off x="640080" y="1737360"/>
-            <a:ext cx="10911535" cy="365760"/>
-          </a:xfrm>
-          <a:prstGeom prst="rect">
-            <a:avLst/>
-          </a:prstGeom>
-          <a:noFill/>
-          <a:ln/>
-        </p:spPr>
-        <p:txBody>
-          <a:bodyPr wrap="square" lIns="0" tIns="0" rIns="0" bIns="0" rtlCol="0" anchor="ctr"/>
-          <a:lstStyle/>
-          <a:p>
-            <a:pPr indent="0" marL="0">
-              <a:buNone/>
-            </a:pPr>
-            <a:r>
-              <a:rPr lang="en-US" sz="1500" b="1" dirty="0">
+            <a:off x="640080" y="1691640"/>
+            <a:ext cx="10911535" cy="320040"/>
+          </a:xfrm>
+          <a:prstGeom prst="rect">
+            <a:avLst/>
+          </a:prstGeom>
+          <a:noFill/>
+          <a:ln/>
+        </p:spPr>
+        <p:txBody>
+          <a:bodyPr wrap="square" lIns="0" tIns="0" rIns="0" bIns="0" rtlCol="0" anchor="ctr"/>
+          <a:lstStyle/>
+          <a:p>
+            <a:pPr indent="0" marL="0">
+              <a:buNone/>
+            </a:pPr>
+            <a:r>
+              <a:rPr lang="en-US" sz="1350" b="1" dirty="0">
                 <a:solidFill>
                   <a:srgbClr val="0A2540"/>
                 </a:solidFill>
@@ -4246,9 +4594,9 @@
                 <a:ea typeface="Microsoft JhengHei" pitchFamily="34" charset="-122"/>
                 <a:cs typeface="Microsoft JhengHei" pitchFamily="34" charset="-120"/>
               </a:rPr>
-              <a:t>Q　對齊到 ISO 19030 哪個層級？</a:t>
-            </a:r>
-            <a:endParaRPr lang="en-US" sz="1500" dirty="0"/>
+              <a:t>Q　用什麼模型？效果多少？</a:t>
+            </a:r>
+            <a:endParaRPr lang="en-US" sz="1350" dirty="0"/>
           </a:p>
         </p:txBody>
       </p:sp>
@@ -4260,8 +4608,8 @@
         </p:nvSpPr>
         <p:spPr>
           <a:xfrm>
-            <a:off x="640080" y="2121408"/>
-            <a:ext cx="10911535" cy="822960"/>
+            <a:off x="640080" y="2020824"/>
+            <a:ext cx="10911535" cy="850392"/>
           </a:xfrm>
           <a:prstGeom prst="rect">
             <a:avLst/>
@@ -4275,12 +4623,12 @@
           <a:p>
             <a:pPr indent="0" marL="0">
               <a:lnSpc>
-                <a:spcPct val="112000"/>
+                <a:spcPct val="108000"/>
               </a:lnSpc>
               <a:buNone/>
             </a:pPr>
             <a:r>
-              <a:rPr lang="en-US" sz="1250" dirty="0">
+              <a:rPr lang="en-US" sz="1150" dirty="0">
                 <a:solidFill>
                   <a:srgbClr val="18293B"/>
                 </a:solidFill>
@@ -4288,9 +4636,9 @@
                 <a:ea typeface="Microsoft JhengHei" pitchFamily="34" charset="-122"/>
                 <a:cs typeface="Microsoft JhengHei" pitchFamily="34" charset="-120"/>
               </a:rPr>
-              <a:t>A　noon-report 粒度的務實改編，不宣稱全合規。用 k=FOC/STW³ 當 performance value 代理，骨架照 ISO：定參考期、控速帶、看偏移；偏離四點有明列表。</a:t>
-            </a:r>
-            <a:endParaRPr lang="en-US" sz="1250" dirty="0"/>
+              <a:t>A　sklearn；物理 baseline→HistGBM→擇優。最佳為樸素 GBM baseline，模擬遮蔽 RMSE 3.51 MT / MAPE 5.22%。更複雜的沒贏過 → 不上。</a:t>
+            </a:r>
+            <a:endParaRPr lang="en-US" sz="1150" dirty="0"/>
           </a:p>
         </p:txBody>
       </p:sp>
@@ -4302,24 +4650,24 @@
         </p:nvSpPr>
         <p:spPr>
           <a:xfrm>
-            <a:off x="640080" y="3154680"/>
-            <a:ext cx="10911535" cy="365760"/>
-          </a:xfrm>
-          <a:prstGeom prst="rect">
-            <a:avLst/>
-          </a:prstGeom>
-          <a:noFill/>
-          <a:ln/>
-        </p:spPr>
-        <p:txBody>
-          <a:bodyPr wrap="square" lIns="0" tIns="0" rIns="0" bIns="0" rtlCol="0" anchor="ctr"/>
-          <a:lstStyle/>
-          <a:p>
-            <a:pPr indent="0" marL="0">
-              <a:buNone/>
-            </a:pPr>
-            <a:r>
-              <a:rPr lang="en-US" sz="1500" b="1" dirty="0">
+            <a:off x="640080" y="2926080"/>
+            <a:ext cx="10911535" cy="320040"/>
+          </a:xfrm>
+          <a:prstGeom prst="rect">
+            <a:avLst/>
+          </a:prstGeom>
+          <a:noFill/>
+          <a:ln/>
+        </p:spPr>
+        <p:txBody>
+          <a:bodyPr wrap="square" lIns="0" tIns="0" rIns="0" bIns="0" rtlCol="0" anchor="ctr"/>
+          <a:lstStyle/>
+          <a:p>
+            <a:pPr indent="0" marL="0">
+              <a:buNone/>
+            </a:pPr>
+            <a:r>
+              <a:rPr lang="en-US" sz="1350" b="1" dirty="0">
                 <a:solidFill>
                   <a:srgbClr val="0A2540"/>
                 </a:solidFill>
@@ -4327,9 +4675,877 @@
                 <a:ea typeface="Microsoft JhengHei" pitchFamily="34" charset="-122"/>
                 <a:cs typeface="Microsoft JhengHei" pitchFamily="34" charset="-120"/>
               </a:rPr>
+              <a:t>Q　怎麼確定沒偷看答案？</a:t>
+            </a:r>
+            <a:endParaRPr lang="en-US" sz="1350" dirty="0"/>
+          </a:p>
+        </p:txBody>
+      </p:sp>
+      <p:sp>
+        <p:nvSpPr>
+          <p:cNvPr id="7" name="Text 5"/>
+          <p:cNvSpPr/>
+          <p:nvPr/>
+        </p:nvSpPr>
+        <p:spPr>
+          <a:xfrm>
+            <a:off x="640080" y="3255264"/>
+            <a:ext cx="10911535" cy="850392"/>
+          </a:xfrm>
+          <a:prstGeom prst="rect">
+            <a:avLst/>
+          </a:prstGeom>
+          <a:noFill/>
+          <a:ln/>
+        </p:spPr>
+        <p:txBody>
+          <a:bodyPr wrap="square" lIns="0" tIns="0" rIns="0" bIns="0" rtlCol="0" anchor="ctr"/>
+          <a:lstStyle/>
+          <a:p>
+            <a:pPr indent="0" marL="0">
+              <a:lnSpc>
+                <a:spcPct val="108000"/>
+              </a:lnSpc>
+              <a:buNone/>
+            </a:pPr>
+            <a:r>
+              <a:rPr lang="en-US" sz="1150" dirty="0">
+                <a:solidFill>
+                  <a:srgbClr val="18293B"/>
+                </a:solidFill>
+                <a:latin typeface="Microsoft JhengHei" pitchFamily="34" charset="0"/>
+                <a:ea typeface="Microsoft JhengHei" pitchFamily="34" charset="-122"/>
+                <a:cs typeface="Microsoft JhengHei" pitchFamily="34" charset="-120"/>
+              </a:rPr>
+              <a:t>A　不用隨機 K-fold。在可見船上模擬真實遮蔽（事件後合格日窗藏答案再預測、逐窗評分）+ GroupKFold 確認跨船遷移。</a:t>
+            </a:r>
+            <a:endParaRPr lang="en-US" sz="1150" dirty="0"/>
+          </a:p>
+        </p:txBody>
+      </p:sp>
+      <p:sp>
+        <p:nvSpPr>
+          <p:cNvPr id="8" name="Text 6"/>
+          <p:cNvSpPr/>
+          <p:nvPr/>
+        </p:nvSpPr>
+        <p:spPr>
+          <a:xfrm>
+            <a:off x="640080" y="4160520"/>
+            <a:ext cx="10911535" cy="320040"/>
+          </a:xfrm>
+          <a:prstGeom prst="rect">
+            <a:avLst/>
+          </a:prstGeom>
+          <a:noFill/>
+          <a:ln/>
+        </p:spPr>
+        <p:txBody>
+          <a:bodyPr wrap="square" lIns="0" tIns="0" rIns="0" bIns="0" rtlCol="0" anchor="ctr"/>
+          <a:lstStyle/>
+          <a:p>
+            <a:pPr indent="0" marL="0">
+              <a:buNone/>
+            </a:pPr>
+            <a:r>
+              <a:rPr lang="en-US" sz="1350" b="1" dirty="0">
+                <a:solidFill>
+                  <a:srgbClr val="0A2540"/>
+                </a:solidFill>
+                <a:latin typeface="Microsoft JhengHei" pitchFamily="34" charset="0"/>
+                <a:ea typeface="Microsoft JhengHei" pitchFamily="34" charset="-122"/>
+                <a:cs typeface="Microsoft JhengHei" pitchFamily="34" charset="-120"/>
+              </a:rPr>
+              <a:t>Q　RPM/SFOC 不是能反推油耗？算洩漏？</a:t>
+            </a:r>
+            <a:endParaRPr lang="en-US" sz="1350" dirty="0"/>
+          </a:p>
+        </p:txBody>
+      </p:sp>
+      <p:sp>
+        <p:nvSpPr>
+          <p:cNvPr id="9" name="Text 7"/>
+          <p:cNvSpPr/>
+          <p:nvPr/>
+        </p:nvSpPr>
+        <p:spPr>
+          <a:xfrm>
+            <a:off x="640080" y="4489704"/>
+            <a:ext cx="10911535" cy="850392"/>
+          </a:xfrm>
+          <a:prstGeom prst="rect">
+            <a:avLst/>
+          </a:prstGeom>
+          <a:noFill/>
+          <a:ln/>
+        </p:spPr>
+        <p:txBody>
+          <a:bodyPr wrap="square" lIns="0" tIns="0" rIns="0" bIns="0" rtlCol="0" anchor="ctr"/>
+          <a:lstStyle/>
+          <a:p>
+            <a:pPr indent="0" marL="0">
+              <a:lnSpc>
+                <a:spcPct val="108000"/>
+              </a:lnSpc>
+              <a:buNone/>
+            </a:pPr>
+            <a:r>
+              <a:rPr lang="en-US" sz="1150" dirty="0">
+                <a:solidFill>
+                  <a:srgbClr val="18293B"/>
+                </a:solidFill>
+                <a:latin typeface="Microsoft JhengHei" pitchFamily="34" charset="0"/>
+                <a:ea typeface="Microsoft JhengHei" pitchFamily="34" charset="-122"/>
+                <a:cs typeface="Microsoft JhengHei" pitchFamily="34" charset="-120"/>
+              </a:rPr>
+              <a:t>A　H 類（SFOC/馬力/推力）在預測窗本就遮蔽、不用。ME_AVG_RPM 屬可見運轉條件、非答案代理；使用邊界也列入問主辦。</a:t>
+            </a:r>
+            <a:endParaRPr lang="en-US" sz="1150" dirty="0"/>
+          </a:p>
+        </p:txBody>
+      </p:sp>
+      <p:sp>
+        <p:nvSpPr>
+          <p:cNvPr id="10" name="Text 8"/>
+          <p:cNvSpPr/>
+          <p:nvPr/>
+        </p:nvSpPr>
+        <p:spPr>
+          <a:xfrm>
+            <a:off x="640080" y="5394960"/>
+            <a:ext cx="10911535" cy="320040"/>
+          </a:xfrm>
+          <a:prstGeom prst="rect">
+            <a:avLst/>
+          </a:prstGeom>
+          <a:noFill/>
+          <a:ln/>
+        </p:spPr>
+        <p:txBody>
+          <a:bodyPr wrap="square" lIns="0" tIns="0" rIns="0" bIns="0" rtlCol="0" anchor="ctr"/>
+          <a:lstStyle/>
+          <a:p>
+            <a:pPr indent="0" marL="0">
+              <a:buNone/>
+            </a:pPr>
+            <a:r>
+              <a:rPr lang="en-US" sz="1350" b="1" dirty="0">
+                <a:solidFill>
+                  <a:srgbClr val="0A2540"/>
+                </a:solidFill>
+                <a:latin typeface="Microsoft JhengHei" pitchFamily="34" charset="0"/>
+                <a:ea typeface="Microsoft JhengHei" pitchFamily="34" charset="-122"/>
+                <a:cs typeface="Microsoft JhengHei" pitchFamily="34" charset="-120"/>
+              </a:rPr>
+              <a:t>Q　模型有信心區間嗎？</a:t>
+            </a:r>
+            <a:endParaRPr lang="en-US" sz="1350" dirty="0"/>
+          </a:p>
+        </p:txBody>
+      </p:sp>
+      <p:sp>
+        <p:nvSpPr>
+          <p:cNvPr id="11" name="Text 9"/>
+          <p:cNvSpPr/>
+          <p:nvPr/>
+        </p:nvSpPr>
+        <p:spPr>
+          <a:xfrm>
+            <a:off x="640080" y="5724144"/>
+            <a:ext cx="10911535" cy="850392"/>
+          </a:xfrm>
+          <a:prstGeom prst="rect">
+            <a:avLst/>
+          </a:prstGeom>
+          <a:noFill/>
+          <a:ln/>
+        </p:spPr>
+        <p:txBody>
+          <a:bodyPr wrap="square" lIns="0" tIns="0" rIns="0" bIns="0" rtlCol="0" anchor="ctr"/>
+          <a:lstStyle/>
+          <a:p>
+            <a:pPr indent="0" marL="0">
+              <a:lnSpc>
+                <a:spcPct val="108000"/>
+              </a:lnSpc>
+              <a:buNone/>
+            </a:pPr>
+            <a:r>
+              <a:rPr lang="en-US" sz="1150" dirty="0">
+                <a:solidFill>
+                  <a:srgbClr val="18293B"/>
+                </a:solidFill>
+                <a:latin typeface="Microsoft JhengHei" pitchFamily="34" charset="0"/>
+                <a:ea typeface="Microsoft JhengHei" pitchFamily="34" charset="-122"/>
+                <a:cs typeface="Microsoft JhengHei" pitchFamily="34" charset="-120"/>
+              </a:rPr>
+              <a:t>A　每格附 ±band（同船型×燃料 slice 的殘差 std）；submission 主檔維持 4 欄 102 列，信心另存輔助檔。</a:t>
+            </a:r>
+            <a:endParaRPr lang="en-US" sz="1150" dirty="0"/>
+          </a:p>
+        </p:txBody>
+      </p:sp>
+    </p:spTree>
+  </p:cSld>
+  <p:clrMapOvr>
+    <a:masterClrMapping/>
+  </p:clrMapOvr>
+</p:sld>
+</file>
+
+<file path=ppt/slides/slide14.xml><?xml version="1.0" encoding="utf-8"?>
+<p:sld xmlns:a="http://schemas.openxmlformats.org/drawingml/2006/main" xmlns:r="http://schemas.openxmlformats.org/officeDocument/2006/relationships" xmlns:p="http://schemas.openxmlformats.org/presentationml/2006/main">
+  <p:cSld name="Slide 14">
+    <p:bg>
+      <p:bgPr>
+        <a:solidFill>
+          <a:srgbClr val="FFFFFF"/>
+        </a:solidFill>
+      </p:bgPr>
+    </p:bg>
+    <p:spTree>
+      <p:nvGrpSpPr>
+        <p:cNvPr id="1" name=""/>
+        <p:cNvGrpSpPr/>
+        <p:nvPr/>
+      </p:nvGrpSpPr>
+      <p:grpSpPr>
+        <a:xfrm>
+          <a:off x="0" y="0"/>
+          <a:ext cx="0" cy="0"/>
+          <a:chOff x="0" y="0"/>
+          <a:chExt cx="0" cy="0"/>
+        </a:xfrm>
+      </p:grpSpPr>
+      <p:sp>
+        <p:nvSpPr>
+          <p:cNvPr id="2" name="Text 0"/>
+          <p:cNvSpPr/>
+          <p:nvPr/>
+        </p:nvSpPr>
+        <p:spPr>
+          <a:xfrm>
+            <a:off x="640080" y="457200"/>
+            <a:ext cx="10911535" cy="274320"/>
+          </a:xfrm>
+          <a:prstGeom prst="rect">
+            <a:avLst/>
+          </a:prstGeom>
+          <a:noFill/>
+          <a:ln/>
+        </p:spPr>
+        <p:txBody>
+          <a:bodyPr wrap="square" lIns="0" tIns="0" rIns="0" bIns="0" rtlCol="0" anchor="ctr"/>
+          <a:lstStyle/>
+          <a:p>
+            <a:pPr indent="0" marL="0">
+              <a:buNone/>
+            </a:pPr>
+            <a:r>
+              <a:rPr lang="en-US" sz="1200" b="1" spc="200" kern="0" dirty="0">
+                <a:solidFill>
+                  <a:srgbClr val="1C7293"/>
+                </a:solidFill>
+                <a:latin typeface="Microsoft JhengHei" pitchFamily="34" charset="0"/>
+                <a:ea typeface="Microsoft JhengHei" pitchFamily="34" charset="-122"/>
+                <a:cs typeface="Microsoft JhengHei" pitchFamily="34" charset="-120"/>
+              </a:rPr>
+              <a:t>Q&amp;A BACKUP</a:t>
+            </a:r>
+            <a:endParaRPr lang="en-US" sz="1200" dirty="0"/>
+          </a:p>
+        </p:txBody>
+      </p:sp>
+      <p:sp>
+        <p:nvSpPr>
+          <p:cNvPr id="3" name="Text 1"/>
+          <p:cNvSpPr/>
+          <p:nvPr/>
+        </p:nvSpPr>
+        <p:spPr>
+          <a:xfrm>
+            <a:off x="640080" y="713232"/>
+            <a:ext cx="10911535" cy="685800"/>
+          </a:xfrm>
+          <a:prstGeom prst="rect">
+            <a:avLst/>
+          </a:prstGeom>
+          <a:noFill/>
+          <a:ln/>
+        </p:spPr>
+        <p:txBody>
+          <a:bodyPr wrap="square" lIns="0" tIns="0" rIns="0" bIns="0" rtlCol="0" anchor="ctr"/>
+          <a:lstStyle/>
+          <a:p>
+            <a:pPr indent="0" marL="0">
+              <a:buNone/>
+            </a:pPr>
+            <a:r>
+              <a:rPr lang="en-US" sz="3000" b="1" dirty="0">
+                <a:solidFill>
+                  <a:srgbClr val="0A2540"/>
+                </a:solidFill>
+                <a:latin typeface="Microsoft JhengHei" pitchFamily="34" charset="0"/>
+                <a:ea typeface="Microsoft JhengHei" pitchFamily="34" charset="-122"/>
+                <a:cs typeface="Microsoft JhengHei" pitchFamily="34" charset="-120"/>
+              </a:rPr>
+              <a:t>Speed Loss / ISO 19030</a:t>
+            </a:r>
+            <a:endParaRPr lang="en-US" sz="3000" dirty="0"/>
+          </a:p>
+        </p:txBody>
+      </p:sp>
+      <p:sp>
+        <p:nvSpPr>
+          <p:cNvPr id="4" name="Text 2"/>
+          <p:cNvSpPr/>
+          <p:nvPr/>
+        </p:nvSpPr>
+        <p:spPr>
+          <a:xfrm>
+            <a:off x="640080" y="1691640"/>
+            <a:ext cx="10911535" cy="320040"/>
+          </a:xfrm>
+          <a:prstGeom prst="rect">
+            <a:avLst/>
+          </a:prstGeom>
+          <a:noFill/>
+          <a:ln/>
+        </p:spPr>
+        <p:txBody>
+          <a:bodyPr wrap="square" lIns="0" tIns="0" rIns="0" bIns="0" rtlCol="0" anchor="ctr"/>
+          <a:lstStyle/>
+          <a:p>
+            <a:pPr indent="0" marL="0">
+              <a:buNone/>
+            </a:pPr>
+            <a:r>
+              <a:rPr lang="en-US" sz="1350" b="1" dirty="0">
+                <a:solidFill>
+                  <a:srgbClr val="0A2540"/>
+                </a:solidFill>
+                <a:latin typeface="Microsoft JhengHei" pitchFamily="34" charset="0"/>
+                <a:ea typeface="Microsoft JhengHei" pitchFamily="34" charset="-122"/>
+                <a:cs typeface="Microsoft JhengHei" pitchFamily="34" charset="-120"/>
+              </a:rPr>
+              <a:t>Q　對齊 ISO 19030 哪個層級？</a:t>
+            </a:r>
+            <a:endParaRPr lang="en-US" sz="1350" dirty="0"/>
+          </a:p>
+        </p:txBody>
+      </p:sp>
+      <p:sp>
+        <p:nvSpPr>
+          <p:cNvPr id="5" name="Text 3"/>
+          <p:cNvSpPr/>
+          <p:nvPr/>
+        </p:nvSpPr>
+        <p:spPr>
+          <a:xfrm>
+            <a:off x="640080" y="2020824"/>
+            <a:ext cx="10911535" cy="850392"/>
+          </a:xfrm>
+          <a:prstGeom prst="rect">
+            <a:avLst/>
+          </a:prstGeom>
+          <a:noFill/>
+          <a:ln/>
+        </p:spPr>
+        <p:txBody>
+          <a:bodyPr wrap="square" lIns="0" tIns="0" rIns="0" bIns="0" rtlCol="0" anchor="ctr"/>
+          <a:lstStyle/>
+          <a:p>
+            <a:pPr indent="0" marL="0">
+              <a:lnSpc>
+                <a:spcPct val="108000"/>
+              </a:lnSpc>
+              <a:buNone/>
+            </a:pPr>
+            <a:r>
+              <a:rPr lang="en-US" sz="1150" dirty="0">
+                <a:solidFill>
+                  <a:srgbClr val="18293B"/>
+                </a:solidFill>
+                <a:latin typeface="Microsoft JhengHei" pitchFamily="34" charset="0"/>
+                <a:ea typeface="Microsoft JhengHei" pitchFamily="34" charset="-122"/>
+                <a:cs typeface="Microsoft JhengHei" pitchFamily="34" charset="-120"/>
+              </a:rPr>
+              <a:t>A　noon-report 粒度務實改編，不宣稱全合規。k=FOC/STW³ 當 performance value 代理，骨架照 ISO：定參考期、控速帶、看偏移；偏離四點有明列表。</a:t>
+            </a:r>
+            <a:endParaRPr lang="en-US" sz="1150" dirty="0"/>
+          </a:p>
+        </p:txBody>
+      </p:sp>
+      <p:sp>
+        <p:nvSpPr>
+          <p:cNvPr id="6" name="Text 4"/>
+          <p:cNvSpPr/>
+          <p:nvPr/>
+        </p:nvSpPr>
+        <p:spPr>
+          <a:xfrm>
+            <a:off x="640080" y="2926080"/>
+            <a:ext cx="10911535" cy="320040"/>
+          </a:xfrm>
+          <a:prstGeom prst="rect">
+            <a:avLst/>
+          </a:prstGeom>
+          <a:noFill/>
+          <a:ln/>
+        </p:spPr>
+        <p:txBody>
+          <a:bodyPr wrap="square" lIns="0" tIns="0" rIns="0" bIns="0" rtlCol="0" anchor="ctr"/>
+          <a:lstStyle/>
+          <a:p>
+            <a:pPr indent="0" marL="0">
+              <a:buNone/>
+            </a:pPr>
+            <a:r>
+              <a:rPr lang="en-US" sz="1350" b="1" dirty="0">
+                <a:solidFill>
+                  <a:srgbClr val="0A2540"/>
+                </a:solidFill>
+                <a:latin typeface="Microsoft JhengHei" pitchFamily="34" charset="0"/>
+                <a:ea typeface="Microsoft JhengHei" pitchFamily="34" charset="-122"/>
+                <a:cs typeface="Microsoft JhengHei" pitchFamily="34" charset="-120"/>
+              </a:rPr>
+              <a:t>Q　全隊都降速了，怎麼分商業減速與污損？</a:t>
+            </a:r>
+            <a:endParaRPr lang="en-US" sz="1350" dirty="0"/>
+          </a:p>
+        </p:txBody>
+      </p:sp>
+      <p:sp>
+        <p:nvSpPr>
+          <p:cNvPr id="7" name="Text 5"/>
+          <p:cNvSpPr/>
+          <p:nvPr/>
+        </p:nvSpPr>
+        <p:spPr>
+          <a:xfrm>
+            <a:off x="640080" y="3255264"/>
+            <a:ext cx="10911535" cy="850392"/>
+          </a:xfrm>
+          <a:prstGeom prst="rect">
+            <a:avLst/>
+          </a:prstGeom>
+          <a:noFill/>
+          <a:ln/>
+        </p:spPr>
+        <p:txBody>
+          <a:bodyPr wrap="square" lIns="0" tIns="0" rIns="0" bIns="0" rtlCol="0" anchor="ctr"/>
+          <a:lstStyle/>
+          <a:p>
+            <a:pPr indent="0" marL="0">
+              <a:lnSpc>
+                <a:spcPct val="108000"/>
+              </a:lnSpc>
+              <a:buNone/>
+            </a:pPr>
+            <a:r>
+              <a:rPr lang="en-US" sz="1150" dirty="0">
+                <a:solidFill>
+                  <a:srgbClr val="18293B"/>
+                </a:solidFill>
+                <a:latin typeface="Microsoft JhengHei" pitchFamily="34" charset="0"/>
+                <a:ea typeface="Microsoft JhengHei" pitchFamily="34" charset="-122"/>
+                <a:cs typeface="Microsoft JhengHei" pitchFamily="34" charset="-120"/>
+              </a:rPr>
+              <a:t>A　從不比原始 FOC/航速。k 先正規化速度，只在同速帶比；基準取事件後首 10–15 合格日、上限 60 天。減速改變 V 不改變 k。</a:t>
+            </a:r>
+            <a:endParaRPr lang="en-US" sz="1150" dirty="0"/>
+          </a:p>
+        </p:txBody>
+      </p:sp>
+      <p:sp>
+        <p:nvSpPr>
+          <p:cNvPr id="8" name="Text 6"/>
+          <p:cNvSpPr/>
+          <p:nvPr/>
+        </p:nvSpPr>
+        <p:spPr>
+          <a:xfrm>
+            <a:off x="640080" y="4160520"/>
+            <a:ext cx="10911535" cy="320040"/>
+          </a:xfrm>
+          <a:prstGeom prst="rect">
+            <a:avLst/>
+          </a:prstGeom>
+          <a:noFill/>
+          <a:ln/>
+        </p:spPr>
+        <p:txBody>
+          <a:bodyPr wrap="square" lIns="0" tIns="0" rIns="0" bIns="0" rtlCol="0" anchor="ctr"/>
+          <a:lstStyle/>
+          <a:p>
+            <a:pPr indent="0" marL="0">
+              <a:buNone/>
+            </a:pPr>
+            <a:r>
+              <a:rPr lang="en-US" sz="1350" b="1" dirty="0">
+                <a:solidFill>
+                  <a:srgbClr val="0A2540"/>
+                </a:solidFill>
+                <a:latin typeface="Microsoft JhengHei" pitchFamily="34" charset="0"/>
+                <a:ea typeface="Microsoft JhengHei" pitchFamily="34" charset="-122"/>
+                <a:cs typeface="Microsoft JhengHei" pitchFamily="34" charset="-120"/>
+              </a:rPr>
+              <a:t>Q　Speed Loss % 可信嗎？</a:t>
+            </a:r>
+            <a:endParaRPr lang="en-US" sz="1350" dirty="0"/>
+          </a:p>
+        </p:txBody>
+      </p:sp>
+      <p:sp>
+        <p:nvSpPr>
+          <p:cNvPr id="9" name="Text 7"/>
+          <p:cNvSpPr/>
+          <p:nvPr/>
+        </p:nvSpPr>
+        <p:spPr>
+          <a:xfrm>
+            <a:off x="640080" y="4489704"/>
+            <a:ext cx="10911535" cy="850392"/>
+          </a:xfrm>
+          <a:prstGeom prst="rect">
+            <a:avLst/>
+          </a:prstGeom>
+          <a:noFill/>
+          <a:ln/>
+        </p:spPr>
+        <p:txBody>
+          <a:bodyPr wrap="square" lIns="0" tIns="0" rIns="0" bIns="0" rtlCol="0" anchor="ctr"/>
+          <a:lstStyle/>
+          <a:p>
+            <a:pPr indent="0" marL="0">
+              <a:lnSpc>
+                <a:spcPct val="108000"/>
+              </a:lnSpc>
+              <a:buNone/>
+            </a:pPr>
+            <a:r>
+              <a:rPr lang="en-US" sz="1150" dirty="0">
+                <a:solidFill>
+                  <a:srgbClr val="18293B"/>
+                </a:solidFill>
+                <a:latin typeface="Microsoft JhengHei" pitchFamily="34" charset="0"/>
+                <a:ea typeface="Microsoft JhengHei" pitchFamily="34" charset="-122"/>
+                <a:cs typeface="Microsoft JhengHei" pitchFamily="34" charset="-120"/>
+              </a:rPr>
+              <a:t>A　段內對 k 做 Theil-Sen 穩健迴歸（抗離群）；主 KPI 顯示 3.5%（±0.8）· 中信心 · n=12，未解釋殘差一定顯示，不做假精確。</a:t>
+            </a:r>
+            <a:endParaRPr lang="en-US" sz="1150" dirty="0"/>
+          </a:p>
+        </p:txBody>
+      </p:sp>
+      <p:sp>
+        <p:nvSpPr>
+          <p:cNvPr id="10" name="Text 8"/>
+          <p:cNvSpPr/>
+          <p:nvPr/>
+        </p:nvSpPr>
+        <p:spPr>
+          <a:xfrm>
+            <a:off x="640080" y="5394960"/>
+            <a:ext cx="10911535" cy="320040"/>
+          </a:xfrm>
+          <a:prstGeom prst="rect">
+            <a:avLst/>
+          </a:prstGeom>
+          <a:noFill/>
+          <a:ln/>
+        </p:spPr>
+        <p:txBody>
+          <a:bodyPr wrap="square" lIns="0" tIns="0" rIns="0" bIns="0" rtlCol="0" anchor="ctr"/>
+          <a:lstStyle/>
+          <a:p>
+            <a:pPr indent="0" marL="0">
+              <a:buNone/>
+            </a:pPr>
+            <a:r>
+              <a:rPr lang="en-US" sz="1350" b="1" dirty="0">
+                <a:solidFill>
+                  <a:srgbClr val="0A2540"/>
+                </a:solidFill>
+                <a:latin typeface="Microsoft JhengHei" pitchFamily="34" charset="0"/>
+                <a:ea typeface="Microsoft JhengHei" pitchFamily="34" charset="-122"/>
+                <a:cs typeface="Microsoft JhengHei" pitchFamily="34" charset="-120"/>
+              </a:rPr>
+              <a:t>Q　船殼 vs 螺旋槳怎麼拆？</a:t>
+            </a:r>
+            <a:endParaRPr lang="en-US" sz="1350" dirty="0"/>
+          </a:p>
+        </p:txBody>
+      </p:sp>
+      <p:sp>
+        <p:nvSpPr>
+          <p:cNvPr id="11" name="Text 9"/>
+          <p:cNvSpPr/>
+          <p:nvPr/>
+        </p:nvSpPr>
+        <p:spPr>
+          <a:xfrm>
+            <a:off x="640080" y="5724144"/>
+            <a:ext cx="10911535" cy="850392"/>
+          </a:xfrm>
+          <a:prstGeom prst="rect">
+            <a:avLst/>
+          </a:prstGeom>
+          <a:noFill/>
+          <a:ln/>
+        </p:spPr>
+        <p:txBody>
+          <a:bodyPr wrap="square" lIns="0" tIns="0" rIns="0" bIns="0" rtlCol="0" anchor="ctr"/>
+          <a:lstStyle/>
+          <a:p>
+            <a:pPr indent="0" marL="0">
+              <a:lnSpc>
+                <a:spcPct val="108000"/>
+              </a:lnSpc>
+              <a:buNone/>
+            </a:pPr>
+            <a:r>
+              <a:rPr lang="en-US" sz="1150" dirty="0">
+                <a:solidFill>
+                  <a:srgbClr val="18293B"/>
+                </a:solidFill>
+                <a:latin typeface="Microsoft JhengHei" pitchFamily="34" charset="0"/>
+                <a:ea typeface="Microsoft JhengHei" pitchFamily="34" charset="-122"/>
+                <a:cs typeface="Microsoft JhengHei" pitchFamily="34" charset="-120"/>
+              </a:rPr>
+              <a:t>A　隔離區段各量 k 漂移率拆分；區段稀疏時退回標記過的 50/50，明講『因區段不足暫用預設』，不假裝精準。</a:t>
+            </a:r>
+            <a:endParaRPr lang="en-US" sz="1150" dirty="0"/>
+          </a:p>
+        </p:txBody>
+      </p:sp>
+    </p:spTree>
+  </p:cSld>
+  <p:clrMapOvr>
+    <a:masterClrMapping/>
+  </p:clrMapOvr>
+</p:sld>
+</file>
+
+<file path=ppt/slides/slide15.xml><?xml version="1.0" encoding="utf-8"?>
+<p:sld xmlns:a="http://schemas.openxmlformats.org/drawingml/2006/main" xmlns:r="http://schemas.openxmlformats.org/officeDocument/2006/relationships" xmlns:p="http://schemas.openxmlformats.org/presentationml/2006/main">
+  <p:cSld name="Slide 15">
+    <p:bg>
+      <p:bgPr>
+        <a:solidFill>
+          <a:srgbClr val="FFFFFF"/>
+        </a:solidFill>
+      </p:bgPr>
+    </p:bg>
+    <p:spTree>
+      <p:nvGrpSpPr>
+        <p:cNvPr id="1" name=""/>
+        <p:cNvGrpSpPr/>
+        <p:nvPr/>
+      </p:nvGrpSpPr>
+      <p:grpSpPr>
+        <a:xfrm>
+          <a:off x="0" y="0"/>
+          <a:ext cx="0" cy="0"/>
+          <a:chOff x="0" y="0"/>
+          <a:chExt cx="0" cy="0"/>
+        </a:xfrm>
+      </p:grpSpPr>
+      <p:sp>
+        <p:nvSpPr>
+          <p:cNvPr id="2" name="Text 0"/>
+          <p:cNvSpPr/>
+          <p:nvPr/>
+        </p:nvSpPr>
+        <p:spPr>
+          <a:xfrm>
+            <a:off x="640080" y="457200"/>
+            <a:ext cx="10911535" cy="274320"/>
+          </a:xfrm>
+          <a:prstGeom prst="rect">
+            <a:avLst/>
+          </a:prstGeom>
+          <a:noFill/>
+          <a:ln/>
+        </p:spPr>
+        <p:txBody>
+          <a:bodyPr wrap="square" lIns="0" tIns="0" rIns="0" bIns="0" rtlCol="0" anchor="ctr"/>
+          <a:lstStyle/>
+          <a:p>
+            <a:pPr indent="0" marL="0">
+              <a:buNone/>
+            </a:pPr>
+            <a:r>
+              <a:rPr lang="en-US" sz="1200" b="1" spc="200" kern="0" dirty="0">
+                <a:solidFill>
+                  <a:srgbClr val="1C7293"/>
+                </a:solidFill>
+                <a:latin typeface="Microsoft JhengHei" pitchFamily="34" charset="0"/>
+                <a:ea typeface="Microsoft JhengHei" pitchFamily="34" charset="-122"/>
+                <a:cs typeface="Microsoft JhengHei" pitchFamily="34" charset="-120"/>
+              </a:rPr>
+              <a:t>Q&amp;A BACKUP</a:t>
+            </a:r>
+            <a:endParaRPr lang="en-US" sz="1200" dirty="0"/>
+          </a:p>
+        </p:txBody>
+      </p:sp>
+      <p:sp>
+        <p:nvSpPr>
+          <p:cNvPr id="3" name="Text 1"/>
+          <p:cNvSpPr/>
+          <p:nvPr/>
+        </p:nvSpPr>
+        <p:spPr>
+          <a:xfrm>
+            <a:off x="640080" y="713232"/>
+            <a:ext cx="10911535" cy="685800"/>
+          </a:xfrm>
+          <a:prstGeom prst="rect">
+            <a:avLst/>
+          </a:prstGeom>
+          <a:noFill/>
+          <a:ln/>
+        </p:spPr>
+        <p:txBody>
+          <a:bodyPr wrap="square" lIns="0" tIns="0" rIns="0" bIns="0" rtlCol="0" anchor="ctr"/>
+          <a:lstStyle/>
+          <a:p>
+            <a:pPr indent="0" marL="0">
+              <a:buNone/>
+            </a:pPr>
+            <a:r>
+              <a:rPr lang="en-US" sz="3000" b="1" dirty="0">
+                <a:solidFill>
+                  <a:srgbClr val="0A2540"/>
+                </a:solidFill>
+                <a:latin typeface="Microsoft JhengHei" pitchFamily="34" charset="0"/>
+                <a:ea typeface="Microsoft JhengHei" pitchFamily="34" charset="-122"/>
+                <a:cs typeface="Microsoft JhengHei" pitchFamily="34" charset="-120"/>
+              </a:rPr>
+              <a:t>UWI 判讀 · 商務價值</a:t>
+            </a:r>
+            <a:endParaRPr lang="en-US" sz="3000" dirty="0"/>
+          </a:p>
+        </p:txBody>
+      </p:sp>
+      <p:sp>
+        <p:nvSpPr>
+          <p:cNvPr id="4" name="Text 2"/>
+          <p:cNvSpPr/>
+          <p:nvPr/>
+        </p:nvSpPr>
+        <p:spPr>
+          <a:xfrm>
+            <a:off x="640080" y="1691640"/>
+            <a:ext cx="10911535" cy="320040"/>
+          </a:xfrm>
+          <a:prstGeom prst="rect">
+            <a:avLst/>
+          </a:prstGeom>
+          <a:noFill/>
+          <a:ln/>
+        </p:spPr>
+        <p:txBody>
+          <a:bodyPr wrap="square" lIns="0" tIns="0" rIns="0" bIns="0" rtlCol="0" anchor="ctr"/>
+          <a:lstStyle/>
+          <a:p>
+            <a:pPr indent="0" marL="0">
+              <a:buNone/>
+            </a:pPr>
+            <a:r>
+              <a:rPr lang="en-US" sz="1350" b="1" dirty="0">
+                <a:solidFill>
+                  <a:srgbClr val="0A2540"/>
+                </a:solidFill>
+                <a:latin typeface="Microsoft JhengHei" pitchFamily="34" charset="0"/>
+                <a:ea typeface="Microsoft JhengHei" pitchFamily="34" charset="-122"/>
+                <a:cs typeface="Microsoft JhengHei" pitchFamily="34" charset="-120"/>
+              </a:rPr>
               <a:t>Q　UWI 你說不改善，但圖上有變化？</a:t>
             </a:r>
-            <a:endParaRPr lang="en-US" sz="1500" dirty="0"/>
+            <a:endParaRPr lang="en-US" sz="1350" dirty="0"/>
+          </a:p>
+        </p:txBody>
+      </p:sp>
+      <p:sp>
+        <p:nvSpPr>
+          <p:cNvPr id="5" name="Text 3"/>
+          <p:cNvSpPr/>
+          <p:nvPr/>
+        </p:nvSpPr>
+        <p:spPr>
+          <a:xfrm>
+            <a:off x="640080" y="2020824"/>
+            <a:ext cx="10911535" cy="850392"/>
+          </a:xfrm>
+          <a:prstGeom prst="rect">
+            <a:avLst/>
+          </a:prstGeom>
+          <a:noFill/>
+          <a:ln/>
+        </p:spPr>
+        <p:txBody>
+          <a:bodyPr wrap="square" lIns="0" tIns="0" rIns="0" bIns="0" rtlCol="0" anchor="ctr"/>
+          <a:lstStyle/>
+          <a:p>
+            <a:pPr indent="0" marL="0">
+              <a:lnSpc>
+                <a:spcPct val="108000"/>
+              </a:lnSpc>
+              <a:buNone/>
+            </a:pPr>
+            <a:r>
+              <a:rPr lang="en-US" sz="1150" dirty="0">
+                <a:solidFill>
+                  <a:srgbClr val="18293B"/>
+                </a:solidFill>
+                <a:latin typeface="Microsoft JhengHei" pitchFamily="34" charset="0"/>
+                <a:ea typeface="Microsoft JhengHei" pitchFamily="34" charset="-122"/>
+                <a:cs typeface="Microsoft JhengHei" pitchFamily="34" charset="-120"/>
+              </a:rPr>
+              <a:t>A　兩個地方兩種角色：物理先驗放『預測模型污損時鐘不因 UWI 重置』；dashboard 誠實顯示實測 delta+信心，不硬壓成零。刻意分開統計實測與物理先驗。</a:t>
+            </a:r>
+            <a:endParaRPr lang="en-US" sz="1150" dirty="0"/>
+          </a:p>
+        </p:txBody>
+      </p:sp>
+      <p:sp>
+        <p:nvSpPr>
+          <p:cNvPr id="6" name="Text 4"/>
+          <p:cNvSpPr/>
+          <p:nvPr/>
+        </p:nvSpPr>
+        <p:spPr>
+          <a:xfrm>
+            <a:off x="640080" y="2926080"/>
+            <a:ext cx="10911535" cy="320040"/>
+          </a:xfrm>
+          <a:prstGeom prst="rect">
+            <a:avLst/>
+          </a:prstGeom>
+          <a:noFill/>
+          <a:ln/>
+        </p:spPr>
+        <p:txBody>
+          <a:bodyPr wrap="square" lIns="0" tIns="0" rIns="0" bIns="0" rtlCol="0" anchor="ctr"/>
+          <a:lstStyle/>
+          <a:p>
+            <a:pPr indent="0" marL="0">
+              <a:buNone/>
+            </a:pPr>
+            <a:r>
+              <a:rPr lang="en-US" sz="1350" b="1" dirty="0">
+                <a:solidFill>
+                  <a:srgbClr val="0A2540"/>
+                </a:solidFill>
+                <a:latin typeface="Microsoft JhengHei" pitchFamily="34" charset="0"/>
+                <a:ea typeface="Microsoft JhengHei" pitchFamily="34" charset="-122"/>
+                <a:cs typeface="Microsoft JhengHei" pitchFamily="34" charset="-120"/>
+              </a:rPr>
+              <a:t>Q　這系統怎麼幫我省錢？講數字。</a:t>
+            </a:r>
+            <a:endParaRPr lang="en-US" sz="1350" dirty="0"/>
           </a:p>
         </p:txBody>
       </p:sp>
@@ -4341,8 +5557,8 @@
         </p:nvSpPr>
         <p:spPr>
           <a:xfrm>
-            <a:off x="640080" y="3538728"/>
-            <a:ext cx="10911535" cy="822960"/>
+            <a:off x="640080" y="3255264"/>
+            <a:ext cx="10911535" cy="850392"/>
           </a:xfrm>
           <a:prstGeom prst="rect">
             <a:avLst/>
@@ -4356,12 +5572,12 @@
           <a:p>
             <a:pPr indent="0" marL="0">
               <a:lnSpc>
-                <a:spcPct val="112000"/>
+                <a:spcPct val="108000"/>
               </a:lnSpc>
               <a:buNone/>
             </a:pPr>
             <a:r>
-              <a:rPr lang="en-US" sz="1250" dirty="0">
+              <a:rPr lang="en-US" sz="1150" dirty="0">
                 <a:solidFill>
                   <a:srgbClr val="18293B"/>
                 </a:solidFill>
@@ -4369,9 +5585,9 @@
                 <a:ea typeface="Microsoft JhengHei" pitchFamily="34" charset="-122"/>
                 <a:cs typeface="Microsoft JhengHei" pitchFamily="34" charset="-120"/>
               </a:rPr>
-              <a:t>A　兩個地方兩種角色：物理先驗放在『預測模型污損時鐘不因 UWI 重置』；dashboard 誠實顯示實測 delta+信心，不硬壓成零。刻意分開統計實測與物理先驗。</a:t>
-            </a:r>
-            <a:endParaRPr lang="en-US" sz="1250" dirty="0"/>
+              <a:t>A　反事實：把污損時鐘歸零重預測，得每天可省油量、年省金額、回本天數（油價 US$650/MT）。S23 清一次年省近 US$3.9M。</a:t>
+            </a:r>
+            <a:endParaRPr lang="en-US" sz="1150" dirty="0"/>
           </a:p>
         </p:txBody>
       </p:sp>
@@ -4383,24 +5599,24 @@
         </p:nvSpPr>
         <p:spPr>
           <a:xfrm>
-            <a:off x="640080" y="4572000"/>
-            <a:ext cx="10911535" cy="365760"/>
-          </a:xfrm>
-          <a:prstGeom prst="rect">
-            <a:avLst/>
-          </a:prstGeom>
-          <a:noFill/>
-          <a:ln/>
-        </p:spPr>
-        <p:txBody>
-          <a:bodyPr wrap="square" lIns="0" tIns="0" rIns="0" bIns="0" rtlCol="0" anchor="ctr"/>
-          <a:lstStyle/>
-          <a:p>
-            <a:pPr indent="0" marL="0">
-              <a:buNone/>
-            </a:pPr>
-            <a:r>
-              <a:rPr lang="en-US" sz="1500" b="1" dirty="0">
+            <a:off x="640080" y="4160520"/>
+            <a:ext cx="10911535" cy="320040"/>
+          </a:xfrm>
+          <a:prstGeom prst="rect">
+            <a:avLst/>
+          </a:prstGeom>
+          <a:noFill/>
+          <a:ln/>
+        </p:spPr>
+        <p:txBody>
+          <a:bodyPr wrap="square" lIns="0" tIns="0" rIns="0" bIns="0" rtlCol="0" anchor="ctr"/>
+          <a:lstStyle/>
+          <a:p>
+            <a:pPr indent="0" marL="0">
+              <a:buNone/>
+            </a:pPr>
+            <a:r>
+              <a:rPr lang="en-US" sz="1350" b="1" dirty="0">
                 <a:solidFill>
                   <a:srgbClr val="0A2540"/>
                 </a:solidFill>
@@ -4410,7 +5626,7 @@
               </a:rPr>
               <a:t>Q　AI 會自己排清潔嗎？</a:t>
             </a:r>
-            <a:endParaRPr lang="en-US" sz="1500" dirty="0"/>
+            <a:endParaRPr lang="en-US" sz="1350" dirty="0"/>
           </a:p>
         </p:txBody>
       </p:sp>
@@ -4422,8 +5638,8 @@
         </p:nvSpPr>
         <p:spPr>
           <a:xfrm>
-            <a:off x="640080" y="4956048"/>
-            <a:ext cx="10911535" cy="822960"/>
+            <a:off x="640080" y="4489704"/>
+            <a:ext cx="10911535" cy="850392"/>
           </a:xfrm>
           <a:prstGeom prst="rect">
             <a:avLst/>
@@ -4437,12 +5653,12 @@
           <a:p>
             <a:pPr indent="0" marL="0">
               <a:lnSpc>
-                <a:spcPct val="112000"/>
+                <a:spcPct val="108000"/>
               </a:lnSpc>
               <a:buNone/>
             </a:pPr>
             <a:r>
-              <a:rPr lang="en-US" sz="1250" dirty="0">
+              <a:rPr lang="en-US" sz="1150" dirty="0">
                 <a:solidFill>
                   <a:srgbClr val="18293B"/>
                 </a:solidFill>
@@ -4452,7 +5668,522 @@
               </a:rPr>
               <a:t>A　不會，決策支援、人拍板。低信心→先做便宜水下檢查；高信心且回本快→建議清潔。反事實是檢視證據，不是自動指令。</a:t>
             </a:r>
-            <a:endParaRPr lang="en-US" sz="1250" dirty="0"/>
+            <a:endParaRPr lang="en-US" sz="1150" dirty="0"/>
+          </a:p>
+        </p:txBody>
+      </p:sp>
+      <p:sp>
+        <p:nvSpPr>
+          <p:cNvPr id="10" name="Text 8"/>
+          <p:cNvSpPr/>
+          <p:nvPr/>
+        </p:nvSpPr>
+        <p:spPr>
+          <a:xfrm>
+            <a:off x="640080" y="5394960"/>
+            <a:ext cx="10911535" cy="320040"/>
+          </a:xfrm>
+          <a:prstGeom prst="rect">
+            <a:avLst/>
+          </a:prstGeom>
+          <a:noFill/>
+          <a:ln/>
+        </p:spPr>
+        <p:txBody>
+          <a:bodyPr wrap="square" lIns="0" tIns="0" rIns="0" bIns="0" rtlCol="0" anchor="ctr"/>
+          <a:lstStyle/>
+          <a:p>
+            <a:pPr indent="0" marL="0">
+              <a:buNone/>
+            </a:pPr>
+            <a:r>
+              <a:rPr lang="en-US" sz="1350" b="1" dirty="0">
+                <a:solidFill>
+                  <a:srgbClr val="0A2540"/>
+                </a:solidFill>
+                <a:latin typeface="Microsoft JhengHei" pitchFamily="34" charset="0"/>
+                <a:ea typeface="Microsoft JhengHei" pitchFamily="34" charset="-122"/>
+                <a:cs typeface="Microsoft JhengHei" pitchFamily="34" charset="-120"/>
+              </a:rPr>
+              <a:t>Q　資料品質差的日子會硬給建議嗎？</a:t>
+            </a:r>
+            <a:endParaRPr lang="en-US" sz="1350" dirty="0"/>
+          </a:p>
+        </p:txBody>
+      </p:sp>
+      <p:sp>
+        <p:nvSpPr>
+          <p:cNvPr id="11" name="Text 9"/>
+          <p:cNvSpPr/>
+          <p:nvPr/>
+        </p:nvSpPr>
+        <p:spPr>
+          <a:xfrm>
+            <a:off x="640080" y="5724144"/>
+            <a:ext cx="10911535" cy="850392"/>
+          </a:xfrm>
+          <a:prstGeom prst="rect">
+            <a:avLst/>
+          </a:prstGeom>
+          <a:noFill/>
+          <a:ln/>
+        </p:spPr>
+        <p:txBody>
+          <a:bodyPr wrap="square" lIns="0" tIns="0" rIns="0" bIns="0" rtlCol="0" anchor="ctr"/>
+          <a:lstStyle/>
+          <a:p>
+            <a:pPr indent="0" marL="0">
+              <a:lnSpc>
+                <a:spcPct val="108000"/>
+              </a:lnSpc>
+              <a:buNone/>
+            </a:pPr>
+            <a:r>
+              <a:rPr lang="en-US" sz="1150" dirty="0">
+                <a:solidFill>
+                  <a:srgbClr val="18293B"/>
+                </a:solidFill>
+                <a:latin typeface="Microsoft JhengHei" pitchFamily="34" charset="0"/>
+                <a:ea typeface="Microsoft JhengHei" pitchFamily="34" charset="-122"/>
+                <a:cs typeface="Microsoft JhengHei" pitchFamily="34" charset="-120"/>
+              </a:rPr>
+              <a:t>A　被拒列標原因+品質分；可比樣本不足時不出高信心建議，改建議先做檢查。信心與 n 永遠跟著數字顯示。</a:t>
+            </a:r>
+            <a:endParaRPr lang="en-US" sz="1150" dirty="0"/>
+          </a:p>
+        </p:txBody>
+      </p:sp>
+    </p:spTree>
+  </p:cSld>
+  <p:clrMapOvr>
+    <a:masterClrMapping/>
+  </p:clrMapOvr>
+</p:sld>
+</file>
+
+<file path=ppt/slides/slide16.xml><?xml version="1.0" encoding="utf-8"?>
+<p:sld xmlns:a="http://schemas.openxmlformats.org/drawingml/2006/main" xmlns:r="http://schemas.openxmlformats.org/officeDocument/2006/relationships" xmlns:p="http://schemas.openxmlformats.org/presentationml/2006/main">
+  <p:cSld name="Slide 16">
+    <p:bg>
+      <p:bgPr>
+        <a:solidFill>
+          <a:srgbClr val="FFFFFF"/>
+        </a:solidFill>
+      </p:bgPr>
+    </p:bg>
+    <p:spTree>
+      <p:nvGrpSpPr>
+        <p:cNvPr id="1" name=""/>
+        <p:cNvGrpSpPr/>
+        <p:nvPr/>
+      </p:nvGrpSpPr>
+      <p:grpSpPr>
+        <a:xfrm>
+          <a:off x="0" y="0"/>
+          <a:ext cx="0" cy="0"/>
+          <a:chOff x="0" y="0"/>
+          <a:chExt cx="0" cy="0"/>
+        </a:xfrm>
+      </p:grpSpPr>
+      <p:sp>
+        <p:nvSpPr>
+          <p:cNvPr id="2" name="Text 0"/>
+          <p:cNvSpPr/>
+          <p:nvPr/>
+        </p:nvSpPr>
+        <p:spPr>
+          <a:xfrm>
+            <a:off x="640080" y="457200"/>
+            <a:ext cx="10911535" cy="274320"/>
+          </a:xfrm>
+          <a:prstGeom prst="rect">
+            <a:avLst/>
+          </a:prstGeom>
+          <a:noFill/>
+          <a:ln/>
+        </p:spPr>
+        <p:txBody>
+          <a:bodyPr wrap="square" lIns="0" tIns="0" rIns="0" bIns="0" rtlCol="0" anchor="ctr"/>
+          <a:lstStyle/>
+          <a:p>
+            <a:pPr indent="0" marL="0">
+              <a:buNone/>
+            </a:pPr>
+            <a:r>
+              <a:rPr lang="en-US" sz="1200" b="1" spc="200" kern="0" dirty="0">
+                <a:solidFill>
+                  <a:srgbClr val="1C7293"/>
+                </a:solidFill>
+                <a:latin typeface="Microsoft JhengHei" pitchFamily="34" charset="0"/>
+                <a:ea typeface="Microsoft JhengHei" pitchFamily="34" charset="-122"/>
+                <a:cs typeface="Microsoft JhengHei" pitchFamily="34" charset="-120"/>
+              </a:rPr>
+              <a:t>Q&amp;A BACKUP</a:t>
+            </a:r>
+            <a:endParaRPr lang="en-US" sz="1200" dirty="0"/>
+          </a:p>
+        </p:txBody>
+      </p:sp>
+      <p:sp>
+        <p:nvSpPr>
+          <p:cNvPr id="3" name="Text 1"/>
+          <p:cNvSpPr/>
+          <p:nvPr/>
+        </p:nvSpPr>
+        <p:spPr>
+          <a:xfrm>
+            <a:off x="640080" y="713232"/>
+            <a:ext cx="10911535" cy="685800"/>
+          </a:xfrm>
+          <a:prstGeom prst="rect">
+            <a:avLst/>
+          </a:prstGeom>
+          <a:noFill/>
+          <a:ln/>
+        </p:spPr>
+        <p:txBody>
+          <a:bodyPr wrap="square" lIns="0" tIns="0" rIns="0" bIns="0" rtlCol="0" anchor="ctr"/>
+          <a:lstStyle/>
+          <a:p>
+            <a:pPr indent="0" marL="0">
+              <a:buNone/>
+            </a:pPr>
+            <a:r>
+              <a:rPr lang="en-US" sz="3000" b="1" dirty="0">
+                <a:solidFill>
+                  <a:srgbClr val="0A2540"/>
+                </a:solidFill>
+                <a:latin typeface="Microsoft JhengHei" pitchFamily="34" charset="0"/>
+                <a:ea typeface="Microsoft JhengHei" pitchFamily="34" charset="-122"/>
+                <a:cs typeface="Microsoft JhengHei" pitchFamily="34" charset="-120"/>
+              </a:rPr>
+              <a:t>AI · AWS · 限制</a:t>
+            </a:r>
+            <a:endParaRPr lang="en-US" sz="3000" dirty="0"/>
+          </a:p>
+        </p:txBody>
+      </p:sp>
+      <p:sp>
+        <p:nvSpPr>
+          <p:cNvPr id="4" name="Text 2"/>
+          <p:cNvSpPr/>
+          <p:nvPr/>
+        </p:nvSpPr>
+        <p:spPr>
+          <a:xfrm>
+            <a:off x="640080" y="1691640"/>
+            <a:ext cx="10911535" cy="320040"/>
+          </a:xfrm>
+          <a:prstGeom prst="rect">
+            <a:avLst/>
+          </a:prstGeom>
+          <a:noFill/>
+          <a:ln/>
+        </p:spPr>
+        <p:txBody>
+          <a:bodyPr wrap="square" lIns="0" tIns="0" rIns="0" bIns="0" rtlCol="0" anchor="ctr"/>
+          <a:lstStyle/>
+          <a:p>
+            <a:pPr indent="0" marL="0">
+              <a:buNone/>
+            </a:pPr>
+            <a:r>
+              <a:rPr lang="en-US" sz="1350" b="1" dirty="0">
+                <a:solidFill>
+                  <a:srgbClr val="0A2540"/>
+                </a:solidFill>
+                <a:latin typeface="Microsoft JhengHei" pitchFamily="34" charset="0"/>
+                <a:ea typeface="Microsoft JhengHei" pitchFamily="34" charset="-122"/>
+                <a:cs typeface="Microsoft JhengHei" pitchFamily="34" charset="-120"/>
+              </a:rPr>
+              <a:t>Q　AI 扮演什麼角色？怎麼防亂編數字？</a:t>
+            </a:r>
+            <a:endParaRPr lang="en-US" sz="1350" dirty="0"/>
+          </a:p>
+        </p:txBody>
+      </p:sp>
+      <p:sp>
+        <p:nvSpPr>
+          <p:cNvPr id="5" name="Text 3"/>
+          <p:cNvSpPr/>
+          <p:nvPr/>
+        </p:nvSpPr>
+        <p:spPr>
+          <a:xfrm>
+            <a:off x="640080" y="2020824"/>
+            <a:ext cx="10911535" cy="850392"/>
+          </a:xfrm>
+          <a:prstGeom prst="rect">
+            <a:avLst/>
+          </a:prstGeom>
+          <a:noFill/>
+          <a:ln/>
+        </p:spPr>
+        <p:txBody>
+          <a:bodyPr wrap="square" lIns="0" tIns="0" rIns="0" bIns="0" rtlCol="0" anchor="ctr"/>
+          <a:lstStyle/>
+          <a:p>
+            <a:pPr indent="0" marL="0">
+              <a:lnSpc>
+                <a:spcPct val="108000"/>
+              </a:lnSpc>
+              <a:buNone/>
+            </a:pPr>
+            <a:r>
+              <a:rPr lang="en-US" sz="1150" dirty="0">
+                <a:solidFill>
+                  <a:srgbClr val="18293B"/>
+                </a:solidFill>
+                <a:latin typeface="Microsoft JhengHei" pitchFamily="34" charset="0"/>
+                <a:ea typeface="Microsoft JhengHei" pitchFamily="34" charset="-122"/>
+                <a:cs typeface="Microsoft JhengHei" pitchFamily="34" charset="-120"/>
+              </a:rPr>
+              <a:t>A　數字來自計算、語言來自 AI。Bedrock(Claude) 只改寫已算好的指標；guardrail 逐一比對每個數字的引用來源，未引用/引錯即攔——無法發明數字。開發用 Kiro。</a:t>
+            </a:r>
+            <a:endParaRPr lang="en-US" sz="1150" dirty="0"/>
+          </a:p>
+        </p:txBody>
+      </p:sp>
+      <p:sp>
+        <p:nvSpPr>
+          <p:cNvPr id="6" name="Text 4"/>
+          <p:cNvSpPr/>
+          <p:nvPr/>
+        </p:nvSpPr>
+        <p:spPr>
+          <a:xfrm>
+            <a:off x="640080" y="2926080"/>
+            <a:ext cx="10911535" cy="320040"/>
+          </a:xfrm>
+          <a:prstGeom prst="rect">
+            <a:avLst/>
+          </a:prstGeom>
+          <a:noFill/>
+          <a:ln/>
+        </p:spPr>
+        <p:txBody>
+          <a:bodyPr wrap="square" lIns="0" tIns="0" rIns="0" bIns="0" rtlCol="0" anchor="ctr"/>
+          <a:lstStyle/>
+          <a:p>
+            <a:pPr indent="0" marL="0">
+              <a:buNone/>
+            </a:pPr>
+            <a:r>
+              <a:rPr lang="en-US" sz="1350" b="1" dirty="0">
+                <a:solidFill>
+                  <a:srgbClr val="0A2540"/>
+                </a:solidFill>
+                <a:latin typeface="Microsoft JhengHei" pitchFamily="34" charset="0"/>
+                <a:ea typeface="Microsoft JhengHei" pitchFamily="34" charset="-122"/>
+                <a:cs typeface="Microsoft JhengHei" pitchFamily="34" charset="-120"/>
+              </a:rPr>
+              <a:t>Q　架構？成本？為何不上 SageMaker？</a:t>
+            </a:r>
+            <a:endParaRPr lang="en-US" sz="1350" dirty="0"/>
+          </a:p>
+        </p:txBody>
+      </p:sp>
+      <p:sp>
+        <p:nvSpPr>
+          <p:cNvPr id="7" name="Text 5"/>
+          <p:cNvSpPr/>
+          <p:nvPr/>
+        </p:nvSpPr>
+        <p:spPr>
+          <a:xfrm>
+            <a:off x="640080" y="3255264"/>
+            <a:ext cx="10911535" cy="850392"/>
+          </a:xfrm>
+          <a:prstGeom prst="rect">
+            <a:avLst/>
+          </a:prstGeom>
+          <a:noFill/>
+          <a:ln/>
+        </p:spPr>
+        <p:txBody>
+          <a:bodyPr wrap="square" lIns="0" tIns="0" rIns="0" bIns="0" rtlCol="0" anchor="ctr"/>
+          <a:lstStyle/>
+          <a:p>
+            <a:pPr indent="0" marL="0">
+              <a:lnSpc>
+                <a:spcPct val="108000"/>
+              </a:lnSpc>
+              <a:buNone/>
+            </a:pPr>
+            <a:r>
+              <a:rPr lang="en-US" sz="1150" dirty="0">
+                <a:solidFill>
+                  <a:srgbClr val="18293B"/>
+                </a:solidFill>
+                <a:latin typeface="Microsoft JhengHei" pitchFamily="34" charset="0"/>
+                <a:ea typeface="Microsoft JhengHei" pitchFamily="34" charset="-122"/>
+                <a:cs typeface="Microsoft JhengHei" pitchFamily="34" charset="-120"/>
+              </a:rPr>
+              <a:t>A　單一 Spring Boot on App Runner + S3 + DynamoDB + Bedrock + CloudWatch，us-east-1，約 &lt;US$70/月。ISO 19030 本身確定性、樣本少硬煉會過擬合，且複雜模型沒贏過 baseline。</a:t>
+            </a:r>
+            <a:endParaRPr lang="en-US" sz="1150" dirty="0"/>
+          </a:p>
+        </p:txBody>
+      </p:sp>
+      <p:sp>
+        <p:nvSpPr>
+          <p:cNvPr id="8" name="Text 6"/>
+          <p:cNvSpPr/>
+          <p:nvPr/>
+        </p:nvSpPr>
+        <p:spPr>
+          <a:xfrm>
+            <a:off x="640080" y="4160520"/>
+            <a:ext cx="10911535" cy="320040"/>
+          </a:xfrm>
+          <a:prstGeom prst="rect">
+            <a:avLst/>
+          </a:prstGeom>
+          <a:noFill/>
+          <a:ln/>
+        </p:spPr>
+        <p:txBody>
+          <a:bodyPr wrap="square" lIns="0" tIns="0" rIns="0" bIns="0" rtlCol="0" anchor="ctr"/>
+          <a:lstStyle/>
+          <a:p>
+            <a:pPr indent="0" marL="0">
+              <a:buNone/>
+            </a:pPr>
+            <a:r>
+              <a:rPr lang="en-US" sz="1350" b="1" dirty="0">
+                <a:solidFill>
+                  <a:srgbClr val="0A2540"/>
+                </a:solidFill>
+                <a:latin typeface="Microsoft JhengHei" pitchFamily="34" charset="0"/>
+                <a:ea typeface="Microsoft JhengHei" pitchFamily="34" charset="-122"/>
+                <a:cs typeface="Microsoft JhengHei" pitchFamily="34" charset="-120"/>
+              </a:rPr>
+              <a:t>Q　最大的限制是什麼？（主動揭露）</a:t>
+            </a:r>
+            <a:endParaRPr lang="en-US" sz="1350" dirty="0"/>
+          </a:p>
+        </p:txBody>
+      </p:sp>
+      <p:sp>
+        <p:nvSpPr>
+          <p:cNvPr id="9" name="Text 7"/>
+          <p:cNvSpPr/>
+          <p:nvPr/>
+        </p:nvSpPr>
+        <p:spPr>
+          <a:xfrm>
+            <a:off x="640080" y="4489704"/>
+            <a:ext cx="10911535" cy="850392"/>
+          </a:xfrm>
+          <a:prstGeom prst="rect">
+            <a:avLst/>
+          </a:prstGeom>
+          <a:noFill/>
+          <a:ln/>
+        </p:spPr>
+        <p:txBody>
+          <a:bodyPr wrap="square" lIns="0" tIns="0" rIns="0" bIns="0" rtlCol="0" anchor="ctr"/>
+          <a:lstStyle/>
+          <a:p>
+            <a:pPr indent="0" marL="0">
+              <a:lnSpc>
+                <a:spcPct val="108000"/>
+              </a:lnSpc>
+              <a:buNone/>
+            </a:pPr>
+            <a:r>
+              <a:rPr lang="en-US" sz="1150" dirty="0">
+                <a:solidFill>
+                  <a:srgbClr val="18293B"/>
+                </a:solidFill>
+                <a:latin typeface="Microsoft JhengHei" pitchFamily="34" charset="0"/>
+                <a:ea typeface="Microsoft JhengHei" pitchFamily="34" charset="-122"/>
+                <a:cs typeface="Microsoft JhengHei" pitchFamily="34" charset="-120"/>
+              </a:rPr>
+              <a:t>A　①SOG 非對水速度、洋流系統偏差 ②無軸功率、k 是代理 ③歸因稀疏時退 50/50 ④UWI 仍有量測雜訊，呈現而非壓平。都在 UI/偏離表明示。</a:t>
+            </a:r>
+            <a:endParaRPr lang="en-US" sz="1150" dirty="0"/>
+          </a:p>
+        </p:txBody>
+      </p:sp>
+      <p:sp>
+        <p:nvSpPr>
+          <p:cNvPr id="10" name="Text 8"/>
+          <p:cNvSpPr/>
+          <p:nvPr/>
+        </p:nvSpPr>
+        <p:spPr>
+          <a:xfrm>
+            <a:off x="640080" y="5394960"/>
+            <a:ext cx="10911535" cy="320040"/>
+          </a:xfrm>
+          <a:prstGeom prst="rect">
+            <a:avLst/>
+          </a:prstGeom>
+          <a:noFill/>
+          <a:ln/>
+        </p:spPr>
+        <p:txBody>
+          <a:bodyPr wrap="square" lIns="0" tIns="0" rIns="0" bIns="0" rtlCol="0" anchor="ctr"/>
+          <a:lstStyle/>
+          <a:p>
+            <a:pPr indent="0" marL="0">
+              <a:buNone/>
+            </a:pPr>
+            <a:r>
+              <a:rPr lang="en-US" sz="1350" b="1" dirty="0">
+                <a:solidFill>
+                  <a:srgbClr val="0A2540"/>
+                </a:solidFill>
+                <a:latin typeface="Microsoft JhengHei" pitchFamily="34" charset="0"/>
+                <a:ea typeface="Microsoft JhengHei" pitchFamily="34" charset="-122"/>
+                <a:cs typeface="Microsoft JhengHei" pitchFamily="34" charset="-120"/>
+              </a:rPr>
+              <a:t>Q　給更多資料會怎麼強化？</a:t>
+            </a:r>
+            <a:endParaRPr lang="en-US" sz="1350" dirty="0"/>
+          </a:p>
+        </p:txBody>
+      </p:sp>
+      <p:sp>
+        <p:nvSpPr>
+          <p:cNvPr id="11" name="Text 9"/>
+          <p:cNvSpPr/>
+          <p:nvPr/>
+        </p:nvSpPr>
+        <p:spPr>
+          <a:xfrm>
+            <a:off x="640080" y="5724144"/>
+            <a:ext cx="10911535" cy="850392"/>
+          </a:xfrm>
+          <a:prstGeom prst="rect">
+            <a:avLst/>
+          </a:prstGeom>
+          <a:noFill/>
+          <a:ln/>
+        </p:spPr>
+        <p:txBody>
+          <a:bodyPr wrap="square" lIns="0" tIns="0" rIns="0" bIns="0" rtlCol="0" anchor="ctr"/>
+          <a:lstStyle/>
+          <a:p>
+            <a:pPr indent="0" marL="0">
+              <a:lnSpc>
+                <a:spcPct val="108000"/>
+              </a:lnSpc>
+              <a:buNone/>
+            </a:pPr>
+            <a:r>
+              <a:rPr lang="en-US" sz="1150" dirty="0">
+                <a:solidFill>
+                  <a:srgbClr val="18293B"/>
+                </a:solidFill>
+                <a:latin typeface="Microsoft JhengHei" pitchFamily="34" charset="0"/>
+                <a:ea typeface="Microsoft JhengHei" pitchFamily="34" charset="-122"/>
+                <a:cs typeface="Microsoft JhengHei" pitchFamily="34" charset="-120"/>
+              </a:rPr>
+              <a:t>A　軸功率計+對水速度計→升級 ISO 19030 全合規；海試曲線→更準基準；貴司 UWC/PP 恢復幅度紀錄→歸因與 ROI 有 ground truth。框架不改、餵更好量測即升級。</a:t>
+            </a:r>
+            <a:endParaRPr lang="en-US" sz="1150" dirty="0"/>
           </a:p>
         </p:txBody>
       </p:sp>

</xml_diff>